<commit_message>
docs: refine descriptions to emphasize template deconstruction and fidelity
</commit_message>
<xml_diff>
--- a/output/presentation.pptx
+++ b/output/presentation.pptx
@@ -4165,7 +4165,7 @@
                 </a:solidFill>
                 <a:latin typeface="PingFang SC, Inter, sans-serif"/>
               </a:rPr>
-              <a:t>新一代企业级 Agentic AI 核心计算中枢架构（用户优化版）</a:t>
+              <a:t>新一代企业级 Agentic AI 平台三层技术架构</a:t>
             </a:r>
           </a:p>
           <a:p>
@@ -4712,7 +4712,7 @@
                   <a:srgbClr val="0F172A"/>
                 </a:solidFill>
               </a:rPr>
-              <a:t>双模逆向引擎</a:t>
+              <a:t>模板解析解构引擎</a:t>
             </a:r>
           </a:p>
         </p:txBody>
@@ -5542,7 +5542,7 @@
                   <a:srgbClr val="10B981"/>
                 </a:solidFill>
               </a:rPr>
-              <a:t>▲ 双模逆向穿透</a:t>
+              <a:t>▲ 母版规范强穿透</a:t>
             </a:r>
           </a:p>
           <a:p>
@@ -6205,7 +6205,7 @@
                   <a:srgbClr val="475569"/>
                 </a:solidFill>
               </a:rPr>
-              <a:t>模板逆向标准库搭建</a:t>
+              <a:t>模板解析标准库搭建</a:t>
             </a:r>
           </a:p>
           <a:p>

</xml_diff>

<commit_message>
feat: release v1.1.0 - Cognitive Content Architecture & Quality Protocol
- Add 10-dimension Cognitive Content Architecture to data schema and SOP
- Introduce Cognitive Contract, narrative arcs, and inter-slide rhetorical transitions
- Add core/content_auditor.py and cli.py audit command for blueprint inspection
- Inject PowerPoint native Speaker Notes with slide missions and transitions
- Add interactive Cognitive Inspector Drawer (N key) in standalone HTML
- Add content_budget rules to all 4 design presets
- Update unit tests, SKILL.md, README.md, and CHANGELOG.md
</commit_message>
<xml_diff>
--- a/output/presentation.pptx
+++ b/output/presentation.pptx
@@ -6,11 +6,11 @@
   </p:sldMasterIdLst>
   <p:sldIdLst>
     <p:sldId id="256" r:id="rId7"/>
-    <p:sldId id="257" r:id="rId8"/>
-    <p:sldId id="258" r:id="rId9"/>
-    <p:sldId id="259" r:id="rId10"/>
-    <p:sldId id="260" r:id="rId11"/>
-    <p:sldId id="261" r:id="rId12"/>
+    <p:sldId id="257" r:id="rId9"/>
+    <p:sldId id="258" r:id="rId10"/>
+    <p:sldId id="259" r:id="rId11"/>
+    <p:sldId id="260" r:id="rId12"/>
+    <p:sldId id="261" r:id="rId13"/>
   </p:sldIdLst>
   <p:sldSz cx="12191695" cy="6858000" type="screen4x3"/>
   <p:notesSz cx="6858000" cy="9144000"/>
@@ -110,6 +110,886 @@
     </a:lvl9pPr>
   </p:defaultTextStyle>
 </p:presentation>
+</file>
+
+<file path=ppt/notesMasters/notesMaster1.xml><?xml version="1.0" encoding="utf-8"?>
+<p:notesMaster xmlns:a="http://schemas.openxmlformats.org/drawingml/2006/main" xmlns:p="http://schemas.openxmlformats.org/presentationml/2006/main" xmlns:r="http://schemas.openxmlformats.org/officeDocument/2006/relationships">
+  <p:cSld>
+    <p:bg>
+      <p:bgRef idx="1001">
+        <a:schemeClr val="bg1"/>
+      </p:bgRef>
+    </p:bg>
+    <p:spTree>
+      <p:nvGrpSpPr>
+        <p:cNvPr id="1" name=""/>
+        <p:cNvGrpSpPr/>
+        <p:nvPr/>
+      </p:nvGrpSpPr>
+      <p:grpSpPr>
+        <a:xfrm>
+          <a:off x="0" y="0"/>
+          <a:ext cx="0" cy="0"/>
+          <a:chOff x="0" y="0"/>
+          <a:chExt cx="0" cy="0"/>
+        </a:xfrm>
+      </p:grpSpPr>
+      <p:sp>
+        <p:nvSpPr>
+          <p:cNvPr id="2" name="Header Placeholder 1"/>
+          <p:cNvSpPr>
+            <a:spLocks noGrp="1"/>
+          </p:cNvSpPr>
+          <p:nvPr>
+            <p:ph type="hdr" sz="quarter"/>
+          </p:nvPr>
+        </p:nvSpPr>
+        <p:spPr>
+          <a:xfrm>
+            <a:off x="0" y="0"/>
+            <a:ext cx="2971800" cy="457200"/>
+          </a:xfrm>
+          <a:prstGeom prst="rect">
+            <a:avLst/>
+          </a:prstGeom>
+        </p:spPr>
+        <p:txBody>
+          <a:bodyPr vert="horz" lIns="91440" tIns="45720" rIns="91440" bIns="45720" rtlCol="0"/>
+          <a:lstStyle>
+            <a:lvl1pPr algn="l">
+              <a:defRPr sz="1200"/>
+            </a:lvl1pPr>
+          </a:lstStyle>
+          <a:p>
+            <a:endParaRPr lang="en-US"/>
+          </a:p>
+        </p:txBody>
+      </p:sp>
+      <p:sp>
+        <p:nvSpPr>
+          <p:cNvPr id="3" name="Date Placeholder 2"/>
+          <p:cNvSpPr>
+            <a:spLocks noGrp="1"/>
+          </p:cNvSpPr>
+          <p:nvPr>
+            <p:ph type="dt" idx="1"/>
+          </p:nvPr>
+        </p:nvSpPr>
+        <p:spPr>
+          <a:xfrm>
+            <a:off x="3884613" y="0"/>
+            <a:ext cx="2971800" cy="457200"/>
+          </a:xfrm>
+          <a:prstGeom prst="rect">
+            <a:avLst/>
+          </a:prstGeom>
+        </p:spPr>
+        <p:txBody>
+          <a:bodyPr vert="horz" lIns="91440" tIns="45720" rIns="91440" bIns="45720" rtlCol="0"/>
+          <a:lstStyle>
+            <a:lvl1pPr algn="r">
+              <a:defRPr sz="1200"/>
+            </a:lvl1pPr>
+          </a:lstStyle>
+          <a:p>
+            <a:fld id="{0F89C1C7-3DCD-1040-A9CF-14679D8B5DDD}" type="datetimeFigureOut">
+              <a:rPr lang="en-US" smtClean="0"/>
+              <a:t>10/17/16</a:t>
+            </a:fld>
+            <a:endParaRPr lang="en-US"/>
+          </a:p>
+        </p:txBody>
+      </p:sp>
+      <p:sp>
+        <p:nvSpPr>
+          <p:cNvPr id="4" name="Slide Image Placeholder 3"/>
+          <p:cNvSpPr>
+            <a:spLocks noGrp="1" noRot="1" noChangeAspect="1"/>
+          </p:cNvSpPr>
+          <p:nvPr>
+            <p:ph type="sldImg" idx="2"/>
+          </p:nvPr>
+        </p:nvSpPr>
+        <p:spPr>
+          <a:xfrm>
+            <a:off x="1143000" y="685800"/>
+            <a:ext cx="4572000" cy="3429000"/>
+          </a:xfrm>
+          <a:prstGeom prst="rect">
+            <a:avLst/>
+          </a:prstGeom>
+          <a:noFill/>
+          <a:ln w="12700">
+            <a:solidFill>
+              <a:prstClr val="black"/>
+            </a:solidFill>
+          </a:ln>
+        </p:spPr>
+        <p:txBody>
+          <a:bodyPr vert="horz" lIns="91440" tIns="45720" rIns="91440" bIns="45720" rtlCol="0" anchor="ctr"/>
+          <a:lstStyle/>
+          <a:p>
+            <a:endParaRPr lang="en-US"/>
+          </a:p>
+        </p:txBody>
+      </p:sp>
+      <p:sp>
+        <p:nvSpPr>
+          <p:cNvPr id="5" name="Notes Placeholder 4"/>
+          <p:cNvSpPr>
+            <a:spLocks noGrp="1"/>
+          </p:cNvSpPr>
+          <p:nvPr>
+            <p:ph type="body" sz="quarter" idx="3"/>
+          </p:nvPr>
+        </p:nvSpPr>
+        <p:spPr>
+          <a:xfrm>
+            <a:off x="685800" y="4343400"/>
+            <a:ext cx="5486400" cy="4114800"/>
+          </a:xfrm>
+          <a:prstGeom prst="rect">
+            <a:avLst/>
+          </a:prstGeom>
+        </p:spPr>
+        <p:txBody>
+          <a:bodyPr vert="horz" lIns="91440" tIns="45720" rIns="91440" bIns="45720" rtlCol="0"/>
+          <a:lstStyle/>
+          <a:p>
+            <a:pPr lvl="0"/>
+            <a:r>
+              <a:rPr lang="en-US" smtClean="0"/>
+              <a:t>Click to edit Master text styles</a:t>
+            </a:r>
+          </a:p>
+          <a:p>
+            <a:pPr lvl="1"/>
+            <a:r>
+              <a:rPr lang="en-US" smtClean="0"/>
+              <a:t>Second level</a:t>
+            </a:r>
+          </a:p>
+          <a:p>
+            <a:pPr lvl="2"/>
+            <a:r>
+              <a:rPr lang="en-US" smtClean="0"/>
+              <a:t>Third level</a:t>
+            </a:r>
+          </a:p>
+          <a:p>
+            <a:pPr lvl="3"/>
+            <a:r>
+              <a:rPr lang="en-US" smtClean="0"/>
+              <a:t>Fourth level</a:t>
+            </a:r>
+          </a:p>
+          <a:p>
+            <a:pPr lvl="4"/>
+            <a:r>
+              <a:rPr lang="en-US" smtClean="0"/>
+              <a:t>Fifth level</a:t>
+            </a:r>
+            <a:endParaRPr lang="en-US"/>
+          </a:p>
+        </p:txBody>
+      </p:sp>
+      <p:sp>
+        <p:nvSpPr>
+          <p:cNvPr id="6" name="Footer Placeholder 5"/>
+          <p:cNvSpPr>
+            <a:spLocks noGrp="1"/>
+          </p:cNvSpPr>
+          <p:nvPr>
+            <p:ph type="ftr" sz="quarter" idx="4"/>
+          </p:nvPr>
+        </p:nvSpPr>
+        <p:spPr>
+          <a:xfrm>
+            <a:off x="0" y="8685213"/>
+            <a:ext cx="2971800" cy="457200"/>
+          </a:xfrm>
+          <a:prstGeom prst="rect">
+            <a:avLst/>
+          </a:prstGeom>
+        </p:spPr>
+        <p:txBody>
+          <a:bodyPr vert="horz" lIns="91440" tIns="45720" rIns="91440" bIns="45720" rtlCol="0" anchor="b"/>
+          <a:lstStyle>
+            <a:lvl1pPr algn="l">
+              <a:defRPr sz="1200"/>
+            </a:lvl1pPr>
+          </a:lstStyle>
+          <a:p>
+            <a:endParaRPr lang="en-US"/>
+          </a:p>
+        </p:txBody>
+      </p:sp>
+      <p:sp>
+        <p:nvSpPr>
+          <p:cNvPr id="7" name="Slide Number Placeholder 6"/>
+          <p:cNvSpPr>
+            <a:spLocks noGrp="1"/>
+          </p:cNvSpPr>
+          <p:nvPr>
+            <p:ph type="sldNum" sz="quarter" idx="5"/>
+          </p:nvPr>
+        </p:nvSpPr>
+        <p:spPr>
+          <a:xfrm>
+            <a:off x="3884613" y="8685213"/>
+            <a:ext cx="2971800" cy="457200"/>
+          </a:xfrm>
+          <a:prstGeom prst="rect">
+            <a:avLst/>
+          </a:prstGeom>
+        </p:spPr>
+        <p:txBody>
+          <a:bodyPr vert="horz" lIns="91440" tIns="45720" rIns="91440" bIns="45720" rtlCol="0" anchor="b"/>
+          <a:lstStyle>
+            <a:lvl1pPr algn="r">
+              <a:defRPr sz="1200"/>
+            </a:lvl1pPr>
+          </a:lstStyle>
+          <a:p>
+            <a:fld id="{BB5E49A5-4136-284D-997B-48E1D791AD67}" type="slidenum">
+              <a:rPr lang="en-US" smtClean="0"/>
+              <a:t>‹#›</a:t>
+            </a:fld>
+            <a:endParaRPr lang="en-US"/>
+          </a:p>
+        </p:txBody>
+      </p:sp>
+    </p:spTree>
+    <p:extLst>
+      <p:ext uri="{BB962C8B-B14F-4D97-AF65-F5344CB8AC3E}">
+        <p14:creationId xmlns:p14="http://schemas.microsoft.com/office/powerpoint/2010/main" val="2623252185"/>
+      </p:ext>
+    </p:extLst>
+  </p:cSld>
+  <p:clrMap bg1="lt1" tx1="dk1" bg2="lt2" tx2="dk2" accent1="accent1" accent2="accent2" accent3="accent3" accent4="accent4" accent5="accent5" accent6="accent6" hlink="hlink" folHlink="folHlink"/>
+  <p:notesStyle>
+    <a:lvl1pPr marL="0" algn="l" defTabSz="457200" rtl="0" eaLnBrk="1" latinLnBrk="0" hangingPunct="1">
+      <a:defRPr sz="1200" kern="1200">
+        <a:solidFill>
+          <a:schemeClr val="tx1"/>
+        </a:solidFill>
+        <a:latin typeface="+mn-lt"/>
+        <a:ea typeface="+mn-ea"/>
+        <a:cs typeface="+mn-cs"/>
+      </a:defRPr>
+    </a:lvl1pPr>
+    <a:lvl2pPr marL="457200" algn="l" defTabSz="457200" rtl="0" eaLnBrk="1" latinLnBrk="0" hangingPunct="1">
+      <a:defRPr sz="1200" kern="1200">
+        <a:solidFill>
+          <a:schemeClr val="tx1"/>
+        </a:solidFill>
+        <a:latin typeface="+mn-lt"/>
+        <a:ea typeface="+mn-ea"/>
+        <a:cs typeface="+mn-cs"/>
+      </a:defRPr>
+    </a:lvl2pPr>
+    <a:lvl3pPr marL="914400" algn="l" defTabSz="457200" rtl="0" eaLnBrk="1" latinLnBrk="0" hangingPunct="1">
+      <a:defRPr sz="1200" kern="1200">
+        <a:solidFill>
+          <a:schemeClr val="tx1"/>
+        </a:solidFill>
+        <a:latin typeface="+mn-lt"/>
+        <a:ea typeface="+mn-ea"/>
+        <a:cs typeface="+mn-cs"/>
+      </a:defRPr>
+    </a:lvl3pPr>
+    <a:lvl4pPr marL="1371600" algn="l" defTabSz="457200" rtl="0" eaLnBrk="1" latinLnBrk="0" hangingPunct="1">
+      <a:defRPr sz="1200" kern="1200">
+        <a:solidFill>
+          <a:schemeClr val="tx1"/>
+        </a:solidFill>
+        <a:latin typeface="+mn-lt"/>
+        <a:ea typeface="+mn-ea"/>
+        <a:cs typeface="+mn-cs"/>
+      </a:defRPr>
+    </a:lvl4pPr>
+    <a:lvl5pPr marL="1828800" algn="l" defTabSz="457200" rtl="0" eaLnBrk="1" latinLnBrk="0" hangingPunct="1">
+      <a:defRPr sz="1200" kern="1200">
+        <a:solidFill>
+          <a:schemeClr val="tx1"/>
+        </a:solidFill>
+        <a:latin typeface="+mn-lt"/>
+        <a:ea typeface="+mn-ea"/>
+        <a:cs typeface="+mn-cs"/>
+      </a:defRPr>
+    </a:lvl5pPr>
+    <a:lvl6pPr marL="2286000" algn="l" defTabSz="457200" rtl="0" eaLnBrk="1" latinLnBrk="0" hangingPunct="1">
+      <a:defRPr sz="1200" kern="1200">
+        <a:solidFill>
+          <a:schemeClr val="tx1"/>
+        </a:solidFill>
+        <a:latin typeface="+mn-lt"/>
+        <a:ea typeface="+mn-ea"/>
+        <a:cs typeface="+mn-cs"/>
+      </a:defRPr>
+    </a:lvl6pPr>
+    <a:lvl7pPr marL="2743200" algn="l" defTabSz="457200" rtl="0" eaLnBrk="1" latinLnBrk="0" hangingPunct="1">
+      <a:defRPr sz="1200" kern="1200">
+        <a:solidFill>
+          <a:schemeClr val="tx1"/>
+        </a:solidFill>
+        <a:latin typeface="+mn-lt"/>
+        <a:ea typeface="+mn-ea"/>
+        <a:cs typeface="+mn-cs"/>
+      </a:defRPr>
+    </a:lvl7pPr>
+    <a:lvl8pPr marL="3200400" algn="l" defTabSz="457200" rtl="0" eaLnBrk="1" latinLnBrk="0" hangingPunct="1">
+      <a:defRPr sz="1200" kern="1200">
+        <a:solidFill>
+          <a:schemeClr val="tx1"/>
+        </a:solidFill>
+        <a:latin typeface="+mn-lt"/>
+        <a:ea typeface="+mn-ea"/>
+        <a:cs typeface="+mn-cs"/>
+      </a:defRPr>
+    </a:lvl8pPr>
+    <a:lvl9pPr marL="3657600" algn="l" defTabSz="457200" rtl="0" eaLnBrk="1" latinLnBrk="0" hangingPunct="1">
+      <a:defRPr sz="1200" kern="1200">
+        <a:solidFill>
+          <a:schemeClr val="tx1"/>
+        </a:solidFill>
+        <a:latin typeface="+mn-lt"/>
+        <a:ea typeface="+mn-ea"/>
+        <a:cs typeface="+mn-cs"/>
+      </a:defRPr>
+    </a:lvl9pPr>
+  </p:notesStyle>
+</p:notesMaster>
+</file>
+
+<file path=ppt/notesSlides/notesSlide1.xml><?xml version="1.0" encoding="utf-8"?>
+<p:notes xmlns:a="http://schemas.openxmlformats.org/drawingml/2006/main" xmlns:p="http://schemas.openxmlformats.org/presentationml/2006/main" xmlns:r="http://schemas.openxmlformats.org/officeDocument/2006/relationships">
+  <p:cSld>
+    <p:spTree>
+      <p:nvGrpSpPr>
+        <p:cNvPr id="1" name=""/>
+        <p:cNvGrpSpPr/>
+        <p:nvPr/>
+      </p:nvGrpSpPr>
+      <p:grpSpPr>
+        <a:xfrm>
+          <a:off x="0" y="0"/>
+          <a:ext cx="0" cy="0"/>
+          <a:chOff x="0" y="0"/>
+          <a:chExt cx="0" cy="0"/>
+        </a:xfrm>
+      </p:grpSpPr>
+      <p:sp>
+        <p:nvSpPr>
+          <p:cNvPr id="2" name="Slide Image Placeholder 1"/>
+          <p:cNvSpPr>
+            <a:spLocks noGrp="1"/>
+          </p:cNvSpPr>
+          <p:nvPr>
+            <p:ph type="sldImg" idx="2"/>
+          </p:nvPr>
+        </p:nvSpPr>
+        <p:spPr/>
+      </p:sp>
+      <p:sp>
+        <p:nvSpPr>
+          <p:cNvPr id="3" name="Notes Placeholder 2"/>
+          <p:cNvSpPr>
+            <a:spLocks noGrp="1"/>
+          </p:cNvSpPr>
+          <p:nvPr>
+            <p:ph type="body" idx="3" sz="quarter"/>
+          </p:nvPr>
+        </p:nvSpPr>
+        <p:spPr/>
+        <p:txBody>
+          <a:bodyPr/>
+          <a:lstStyle/>
+          <a:p>
+            <a:r>
+              <a:t>【认知契约 / Cognitive Contract】</a:t>
+            </a:r>
+          </a:p>
+          <a:p>
+            <a:r>
+              <a:t>• 核心主旨: 从单一认知对话全面迈向自主协同的 Agentic AI 企业级架构演进</a:t>
+            </a:r>
+          </a:p>
+          <a:p>
+            <a:r>
+              <a:t>• 目标受众: CTO 及技术决策委员会 (关注落地可靠性、改造成本与人机交互确定性)</a:t>
+            </a:r>
+          </a:p>
+          <a:p>
+            <a:r>
+              <a:t>• 认知差/痛点: 传统被动方案人工介入成本高达 80%, 固定规则 RPA 面对非结构化长尾场景极其脆弱</a:t>
+            </a:r>
+          </a:p>
+          <a:p>
+            <a:r>
+              <a:t>• 目标行动(Act): 批准 Q2 试点破局阶段技术预研立项并分配专项研发资源</a:t>
+            </a:r>
+          </a:p>
+          <a:p>
+            <a:r>
+              <a:t>------------------------------------</a:t>
+            </a:r>
+          </a:p>
+          <a:p>
+            <a:r>
+              <a:t>【叙事阶段 / Arc】HOOK</a:t>
+            </a:r>
+          </a:p>
+          <a:p>
+            <a:r>
+              <a:t>【单页使命 / Mission】确立核心主张，建立架构评审共识与预期成效</a:t>
+            </a:r>
+          </a:p>
+        </p:txBody>
+      </p:sp>
+      <p:sp>
+        <p:nvSpPr>
+          <p:cNvPr id="4" name="Slide Number Placeholder 3"/>
+          <p:cNvSpPr>
+            <a:spLocks noGrp="1"/>
+          </p:cNvSpPr>
+          <p:nvPr>
+            <p:ph type="sldNum" idx="5" sz="quarter"/>
+          </p:nvPr>
+        </p:nvSpPr>
+        <p:spPr/>
+      </p:sp>
+    </p:spTree>
+  </p:cSld>
+  <p:clrMapOvr>
+    <a:masterClrMapping/>
+  </p:clrMapOvr>
+</p:notes>
+</file>
+
+<file path=ppt/notesSlides/notesSlide2.xml><?xml version="1.0" encoding="utf-8"?>
+<p:notes xmlns:a="http://schemas.openxmlformats.org/drawingml/2006/main" xmlns:p="http://schemas.openxmlformats.org/presentationml/2006/main" xmlns:r="http://schemas.openxmlformats.org/officeDocument/2006/relationships">
+  <p:cSld>
+    <p:spTree>
+      <p:nvGrpSpPr>
+        <p:cNvPr id="1" name=""/>
+        <p:cNvGrpSpPr/>
+        <p:nvPr/>
+      </p:nvGrpSpPr>
+      <p:grpSpPr>
+        <a:xfrm>
+          <a:off x="0" y="0"/>
+          <a:ext cx="0" cy="0"/>
+          <a:chOff x="0" y="0"/>
+          <a:chExt cx="0" cy="0"/>
+        </a:xfrm>
+      </p:grpSpPr>
+      <p:sp>
+        <p:nvSpPr>
+          <p:cNvPr id="2" name="Slide Image Placeholder 1"/>
+          <p:cNvSpPr>
+            <a:spLocks noGrp="1"/>
+          </p:cNvSpPr>
+          <p:nvPr>
+            <p:ph type="sldImg" idx="2"/>
+          </p:nvPr>
+        </p:nvSpPr>
+        <p:spPr/>
+      </p:sp>
+      <p:sp>
+        <p:nvSpPr>
+          <p:cNvPr id="3" name="Notes Placeholder 2"/>
+          <p:cNvSpPr>
+            <a:spLocks noGrp="1"/>
+          </p:cNvSpPr>
+          <p:nvPr>
+            <p:ph type="body" idx="3" sz="quarter"/>
+          </p:nvPr>
+        </p:nvSpPr>
+        <p:spPr/>
+        <p:txBody>
+          <a:bodyPr/>
+          <a:lstStyle/>
+          <a:p>
+            <a:r>
+              <a:t>【叙事阶段 / Arc】CONFLICT</a:t>
+            </a:r>
+          </a:p>
+          <a:p>
+            <a:r>
+              <a:t>【单页使命 / Mission】击穿听众对现有方案的侥幸心理，建立系统性重构的紧迫性</a:t>
+            </a:r>
+          </a:p>
+          <a:p>
+            <a:r>
+              <a:t>【承上启下 / Transition】【冲突】然而现存的两大传统方案，在真实生产环境下均已触碰天花板</a:t>
+            </a:r>
+          </a:p>
+          <a:p>
+            <a:r>
+              <a:t>【核心论据 / Evidence】传统方案人工介入成本高达 80%，而 Agentic 系统综合效率提升 400%+</a:t>
+            </a:r>
+          </a:p>
+        </p:txBody>
+      </p:sp>
+      <p:sp>
+        <p:nvSpPr>
+          <p:cNvPr id="4" name="Slide Number Placeholder 3"/>
+          <p:cNvSpPr>
+            <a:spLocks noGrp="1"/>
+          </p:cNvSpPr>
+          <p:nvPr>
+            <p:ph type="sldNum" idx="5" sz="quarter"/>
+          </p:nvPr>
+        </p:nvSpPr>
+        <p:spPr/>
+      </p:sp>
+    </p:spTree>
+  </p:cSld>
+  <p:clrMapOvr>
+    <a:masterClrMapping/>
+  </p:clrMapOvr>
+</p:notes>
+</file>
+
+<file path=ppt/notesSlides/notesSlide3.xml><?xml version="1.0" encoding="utf-8"?>
+<p:notes xmlns:a="http://schemas.openxmlformats.org/drawingml/2006/main" xmlns:p="http://schemas.openxmlformats.org/presentationml/2006/main" xmlns:r="http://schemas.openxmlformats.org/officeDocument/2006/relationships">
+  <p:cSld>
+    <p:spTree>
+      <p:nvGrpSpPr>
+        <p:cNvPr id="1" name=""/>
+        <p:cNvGrpSpPr/>
+        <p:nvPr/>
+      </p:nvGrpSpPr>
+      <p:grpSpPr>
+        <a:xfrm>
+          <a:off x="0" y="0"/>
+          <a:ext cx="0" cy="0"/>
+          <a:chOff x="0" y="0"/>
+          <a:chExt cx="0" cy="0"/>
+        </a:xfrm>
+      </p:grpSpPr>
+      <p:sp>
+        <p:nvSpPr>
+          <p:cNvPr id="2" name="Slide Image Placeholder 1"/>
+          <p:cNvSpPr>
+            <a:spLocks noGrp="1"/>
+          </p:cNvSpPr>
+          <p:nvPr>
+            <p:ph type="sldImg" idx="2"/>
+          </p:nvPr>
+        </p:nvSpPr>
+        <p:spPr/>
+      </p:sp>
+      <p:sp>
+        <p:nvSpPr>
+          <p:cNvPr id="3" name="Notes Placeholder 2"/>
+          <p:cNvSpPr>
+            <a:spLocks noGrp="1"/>
+          </p:cNvSpPr>
+          <p:nvPr>
+            <p:ph type="body" idx="3" sz="quarter"/>
+          </p:nvPr>
+        </p:nvSpPr>
+        <p:spPr/>
+        <p:txBody>
+          <a:bodyPr/>
+          <a:lstStyle/>
+          <a:p>
+            <a:r>
+              <a:t>【叙事阶段 / Arc】BREAKTHROUGH</a:t>
+            </a:r>
+          </a:p>
+          <a:p>
+            <a:r>
+              <a:t>【单页使命 / Mission】给出根本解法，证明平台具备高可用、分层解耦与工具沙箱控制力</a:t>
+            </a:r>
+          </a:p>
+          <a:p>
+            <a:r>
+              <a:t>【承上启下 / Transition】【突破】因此，我们必须构建‘交互-中枢-沙箱’三层闭环架构</a:t>
+            </a:r>
+          </a:p>
+          <a:p>
+            <a:r>
+              <a:t>【核心论据 / Evidence】三层架构严格解耦，沙箱隔离保障企业级安全合规</a:t>
+            </a:r>
+          </a:p>
+        </p:txBody>
+      </p:sp>
+      <p:sp>
+        <p:nvSpPr>
+          <p:cNvPr id="4" name="Slide Number Placeholder 3"/>
+          <p:cNvSpPr>
+            <a:spLocks noGrp="1"/>
+          </p:cNvSpPr>
+          <p:nvPr>
+            <p:ph type="sldNum" idx="5" sz="quarter"/>
+          </p:nvPr>
+        </p:nvSpPr>
+        <p:spPr/>
+      </p:sp>
+    </p:spTree>
+  </p:cSld>
+  <p:clrMapOvr>
+    <a:masterClrMapping/>
+  </p:clrMapOvr>
+</p:notes>
+</file>
+
+<file path=ppt/notesSlides/notesSlide4.xml><?xml version="1.0" encoding="utf-8"?>
+<p:notes xmlns:a="http://schemas.openxmlformats.org/drawingml/2006/main" xmlns:p="http://schemas.openxmlformats.org/presentationml/2006/main" xmlns:r="http://schemas.openxmlformats.org/officeDocument/2006/relationships">
+  <p:cSld>
+    <p:spTree>
+      <p:nvGrpSpPr>
+        <p:cNvPr id="1" name=""/>
+        <p:cNvGrpSpPr/>
+        <p:nvPr/>
+      </p:nvGrpSpPr>
+      <p:grpSpPr>
+        <a:xfrm>
+          <a:off x="0" y="0"/>
+          <a:ext cx="0" cy="0"/>
+          <a:chOff x="0" y="0"/>
+          <a:chExt cx="0" cy="0"/>
+        </a:xfrm>
+      </p:grpSpPr>
+      <p:sp>
+        <p:nvSpPr>
+          <p:cNvPr id="2" name="Slide Image Placeholder 1"/>
+          <p:cNvSpPr>
+            <a:spLocks noGrp="1"/>
+          </p:cNvSpPr>
+          <p:nvPr>
+            <p:ph type="sldImg" idx="2"/>
+          </p:nvPr>
+        </p:nvSpPr>
+        <p:spPr/>
+      </p:sp>
+      <p:sp>
+        <p:nvSpPr>
+          <p:cNvPr id="3" name="Notes Placeholder 2"/>
+          <p:cNvSpPr>
+            <a:spLocks noGrp="1"/>
+          </p:cNvSpPr>
+          <p:nvPr>
+            <p:ph type="body" idx="3" sz="quarter"/>
+          </p:nvPr>
+        </p:nvSpPr>
+        <p:spPr/>
+        <p:txBody>
+          <a:bodyPr/>
+          <a:lstStyle/>
+          <a:p>
+            <a:r>
+              <a:t>【叙事阶段 / Arc】EVIDENCE</a:t>
+            </a:r>
+          </a:p>
+          <a:p>
+            <a:r>
+              <a:t>【单页使命 / Mission】用压倒性量化硬核指标击溃疑虑，提供坚不可摧的商业成效背书</a:t>
+            </a:r>
+          </a:p>
+          <a:p>
+            <a:r>
+              <a:t>【承上启下 / Transition】【实证】方案不仅理论自洽，更在全链路可观测指标上实现跨越式突破</a:t>
+            </a:r>
+          </a:p>
+          <a:p>
+            <a:r>
+              <a:t>【核心论据 / Evidence】94.8% 自主完成率，&lt;8ms 毫秒级感知延迟，45s 极速综合交付</a:t>
+            </a:r>
+          </a:p>
+        </p:txBody>
+      </p:sp>
+      <p:sp>
+        <p:nvSpPr>
+          <p:cNvPr id="4" name="Slide Number Placeholder 3"/>
+          <p:cNvSpPr>
+            <a:spLocks noGrp="1"/>
+          </p:cNvSpPr>
+          <p:nvPr>
+            <p:ph type="sldNum" idx="5" sz="quarter"/>
+          </p:nvPr>
+        </p:nvSpPr>
+        <p:spPr/>
+      </p:sp>
+    </p:spTree>
+  </p:cSld>
+  <p:clrMapOvr>
+    <a:masterClrMapping/>
+  </p:clrMapOvr>
+</p:notes>
+</file>
+
+<file path=ppt/notesSlides/notesSlide5.xml><?xml version="1.0" encoding="utf-8"?>
+<p:notes xmlns:a="http://schemas.openxmlformats.org/drawingml/2006/main" xmlns:p="http://schemas.openxmlformats.org/presentationml/2006/main" xmlns:r="http://schemas.openxmlformats.org/officeDocument/2006/relationships">
+  <p:cSld>
+    <p:spTree>
+      <p:nvGrpSpPr>
+        <p:cNvPr id="1" name=""/>
+        <p:cNvGrpSpPr/>
+        <p:nvPr/>
+      </p:nvGrpSpPr>
+      <p:grpSpPr>
+        <a:xfrm>
+          <a:off x="0" y="0"/>
+          <a:ext cx="0" cy="0"/>
+          <a:chOff x="0" y="0"/>
+          <a:chExt cx="0" cy="0"/>
+        </a:xfrm>
+      </p:grpSpPr>
+      <p:sp>
+        <p:nvSpPr>
+          <p:cNvPr id="2" name="Slide Image Placeholder 1"/>
+          <p:cNvSpPr>
+            <a:spLocks noGrp="1"/>
+          </p:cNvSpPr>
+          <p:nvPr>
+            <p:ph type="sldImg" idx="2"/>
+          </p:nvPr>
+        </p:nvSpPr>
+        <p:spPr/>
+      </p:sp>
+      <p:sp>
+        <p:nvSpPr>
+          <p:cNvPr id="3" name="Notes Placeholder 2"/>
+          <p:cNvSpPr>
+            <a:spLocks noGrp="1"/>
+          </p:cNvSpPr>
+          <p:nvPr>
+            <p:ph type="body" idx="3" sz="quarter"/>
+          </p:nvPr>
+        </p:nvSpPr>
+        <p:spPr/>
+        <p:txBody>
+          <a:bodyPr/>
+          <a:lstStyle/>
+          <a:p>
+            <a:r>
+              <a:t>【叙事阶段 / Arc】PROGRESSION</a:t>
+            </a:r>
+          </a:p>
+          <a:p>
+            <a:r>
+              <a:t>【单页使命 / Mission】给出低风险渐进式落地路径，打消听众对迁移风险的顾虑</a:t>
+            </a:r>
+          </a:p>
+          <a:p>
+            <a:r>
+              <a:t>【承上启下 / Transition】【落地】为确保业务平滑过渡，推行‘试点-建设-推广-生态’四步走路线</a:t>
+            </a:r>
+          </a:p>
+          <a:p>
+            <a:r>
+              <a:t>【核心论据 / Evidence】Q1 试点验证，Q2 平台就绪，Q3 规模推广，Q4 自主进化闭环</a:t>
+            </a:r>
+          </a:p>
+        </p:txBody>
+      </p:sp>
+      <p:sp>
+        <p:nvSpPr>
+          <p:cNvPr id="4" name="Slide Number Placeholder 3"/>
+          <p:cNvSpPr>
+            <a:spLocks noGrp="1"/>
+          </p:cNvSpPr>
+          <p:nvPr>
+            <p:ph type="sldNum" idx="5" sz="quarter"/>
+          </p:nvPr>
+        </p:nvSpPr>
+        <p:spPr/>
+      </p:sp>
+    </p:spTree>
+  </p:cSld>
+  <p:clrMapOvr>
+    <a:masterClrMapping/>
+  </p:clrMapOvr>
+</p:notes>
+</file>
+
+<file path=ppt/notesSlides/notesSlide6.xml><?xml version="1.0" encoding="utf-8"?>
+<p:notes xmlns:a="http://schemas.openxmlformats.org/drawingml/2006/main" xmlns:p="http://schemas.openxmlformats.org/presentationml/2006/main" xmlns:r="http://schemas.openxmlformats.org/officeDocument/2006/relationships">
+  <p:cSld>
+    <p:spTree>
+      <p:nvGrpSpPr>
+        <p:cNvPr id="1" name=""/>
+        <p:cNvGrpSpPr/>
+        <p:nvPr/>
+      </p:nvGrpSpPr>
+      <p:grpSpPr>
+        <a:xfrm>
+          <a:off x="0" y="0"/>
+          <a:ext cx="0" cy="0"/>
+          <a:chOff x="0" y="0"/>
+          <a:chExt cx="0" cy="0"/>
+        </a:xfrm>
+      </p:grpSpPr>
+      <p:sp>
+        <p:nvSpPr>
+          <p:cNvPr id="2" name="Slide Image Placeholder 1"/>
+          <p:cNvSpPr>
+            <a:spLocks noGrp="1"/>
+          </p:cNvSpPr>
+          <p:nvPr>
+            <p:ph type="sldImg" idx="2"/>
+          </p:nvPr>
+        </p:nvSpPr>
+        <p:spPr/>
+      </p:sp>
+      <p:sp>
+        <p:nvSpPr>
+          <p:cNvPr id="3" name="Notes Placeholder 2"/>
+          <p:cNvSpPr>
+            <a:spLocks noGrp="1"/>
+          </p:cNvSpPr>
+          <p:nvPr>
+            <p:ph type="body" idx="3" sz="quarter"/>
+          </p:nvPr>
+        </p:nvSpPr>
+        <p:spPr/>
+        <p:txBody>
+          <a:bodyPr/>
+          <a:lstStyle/>
+          <a:p>
+            <a:r>
+              <a:t>【叙事阶段 / Arc】CALL_TO_ACTION</a:t>
+            </a:r>
+          </a:p>
+          <a:p>
+            <a:r>
+              <a:t>【单页使命 / Mission】发起明确行动号召，锁定立项决策与资源分配动作</a:t>
+            </a:r>
+          </a:p>
+          <a:p>
+            <a:r>
+              <a:t>【承上启下 / Transition】【号召】万事俱备，建议立即启动第一阶段试点立项与研发协同</a:t>
+            </a:r>
+          </a:p>
+          <a:p>
+            <a:r>
+              <a:t>【核心论据 / Evidence】信息充分性与认知契约已就绪，建议立即批准团队编制与算力配额</a:t>
+            </a:r>
+          </a:p>
+        </p:txBody>
+      </p:sp>
+      <p:sp>
+        <p:nvSpPr>
+          <p:cNvPr id="4" name="Slide Number Placeholder 3"/>
+          <p:cNvSpPr>
+            <a:spLocks noGrp="1"/>
+          </p:cNvSpPr>
+          <p:nvPr>
+            <p:ph type="sldNum" idx="5" sz="quarter"/>
+          </p:nvPr>
+        </p:nvSpPr>
+        <p:spPr/>
+      </p:sp>
+    </p:spTree>
+  </p:cSld>
+  <p:clrMapOvr>
+    <a:masterClrMapping/>
+  </p:clrMapOvr>
+</p:notes>
 </file>
 
 <file path=ppt/slideLayouts/slideLayout1.xml><?xml version="1.0" encoding="utf-8"?>
@@ -3415,7 +4295,7 @@
                 </a:solidFill>
                 <a:latin typeface="PingFang SC, Inter, sans-serif"/>
               </a:rPr>
-              <a:t>ANALYSIS</a:t>
+              <a:t>CONFLICT</a:t>
             </a:r>
           </a:p>
         </p:txBody>
@@ -3454,7 +4334,7 @@
                 </a:solidFill>
                 <a:latin typeface="PingFang SC, Inter, sans-serif"/>
               </a:rPr>
-              <a:t>传统 AI 方案 vs Agentic AI 核心维度对比</a:t>
+              <a:t>痛点：传统被动方案与规则 RPA 难以支撑工业级自主闭环</a:t>
             </a:r>
           </a:p>
           <a:p>
@@ -4126,7 +5006,7 @@
                 </a:solidFill>
                 <a:latin typeface="PingFang SC, Inter, sans-serif"/>
               </a:rPr>
-              <a:t>ARCHITECTURE</a:t>
+              <a:t>BREAKTHROUGH</a:t>
             </a:r>
           </a:p>
         </p:txBody>
@@ -4165,7 +5045,7 @@
                 </a:solidFill>
                 <a:latin typeface="PingFang SC, Inter, sans-serif"/>
               </a:rPr>
-              <a:t>新一代企业级 Agentic AI 平台三层技术架构</a:t>
+              <a:t>方案：构建高可用、多租户、安全可信赖的智能体全生命周期中枢</a:t>
             </a:r>
           </a:p>
           <a:p>
@@ -5254,7 +6134,7 @@
                 </a:solidFill>
                 <a:latin typeface="PingFang SC, Inter, sans-serif"/>
               </a:rPr>
-              <a:t>KPI DASHBOARD</a:t>
+              <a:t>EVIDENCE</a:t>
             </a:r>
           </a:p>
         </p:txBody>
@@ -5293,7 +6173,7 @@
                 </a:solidFill>
                 <a:latin typeface="PingFang SC, Inter, sans-serif"/>
               </a:rPr>
-              <a:t>核心效能与业务价值度量指标</a:t>
+              <a:t>成效：端到端任务自主完成率突破 94.8%，工时缩减 90%</a:t>
             </a:r>
           </a:p>
           <a:p>
@@ -5915,7 +6795,7 @@
                 </a:solidFill>
                 <a:latin typeface="PingFang SC, Inter, sans-serif"/>
               </a:rPr>
-              <a:t>ROADMAP</a:t>
+              <a:t>PROGRESSION</a:t>
             </a:r>
           </a:p>
         </p:txBody>
@@ -5954,7 +6834,7 @@
                 </a:solidFill>
                 <a:latin typeface="PingFang SC, Inter, sans-serif"/>
               </a:rPr>
-              <a:t>企业落地推行路线与关键里程碑</a:t>
+              <a:t>路径：分阶段稳步推进智能体在核心业务线的全域渗透</a:t>
             </a:r>
           </a:p>
           <a:p>
@@ -6963,7 +7843,7 @@
         <p:spPr>
           <a:xfrm>
             <a:off x="731520" y="685800"/>
-            <a:ext cx="1645920" cy="292608"/>
+            <a:ext cx="1773936" cy="292608"/>
           </a:xfrm>
           <a:prstGeom prst="roundRect">
             <a:avLst/>
@@ -7003,7 +7883,7 @@
                 </a:solidFill>
                 <a:latin typeface="PingFang SC, Inter, sans-serif"/>
               </a:rPr>
-              <a:t>SUMMARY</a:t>
+              <a:t>CALL_TO_ACTION</a:t>
             </a:r>
           </a:p>
         </p:txBody>
@@ -7042,7 +7922,7 @@
                 </a:solidFill>
                 <a:latin typeface="PingFang SC, Inter, sans-serif"/>
               </a:rPr>
-              <a:t>战略实施建议与收官结论</a:t>
+              <a:t>决议：恪守认知动力学与母版穿透准则，启动 Q1 试点立项</a:t>
             </a:r>
           </a:p>
           <a:p>
@@ -7187,7 +8067,7 @@
                   <a:srgbClr val="0F172A"/>
                 </a:solidFill>
               </a:rPr>
-              <a:t>恪守信息充分性第一准则</a:t>
+              <a:t>恪守认知动力学契约准则</a:t>
             </a:r>
           </a:p>
           <a:p>
@@ -7197,7 +8077,7 @@
                   <a:srgbClr val="475569"/>
                 </a:solidFill>
               </a:rPr>
-              <a:t>在方案设计前坚决完成深度需求探针与企业内部素材注水，杜绝信息贫血时仓促决策。</a:t>
+              <a:t>在方案设计前坚决完成深度需求探针与认知差分析，杜绝信息贫血时仓促决策。</a:t>
             </a:r>
           </a:p>
         </p:txBody>
@@ -7960,4 +8840,324 @@
   </a:objectDefaults>
   <a:extraClrSchemeLst/>
 </a:theme>
+</file>
+
+<file path=ppt/theme/theme2.xml><?xml version="1.0" encoding="utf-8"?>
+<a:theme xmlns:a="http://schemas.openxmlformats.org/drawingml/2006/main" name="Office Theme">
+  <a:themeElements>
+    <a:clrScheme name="Office">
+      <a:dk1>
+        <a:sysClr val="windowText" lastClr="000000"/>
+      </a:dk1>
+      <a:lt1>
+        <a:sysClr val="window" lastClr="FFFFFF"/>
+      </a:lt1>
+      <a:dk2>
+        <a:srgbClr val="1F497D"/>
+      </a:dk2>
+      <a:lt2>
+        <a:srgbClr val="EEECE1"/>
+      </a:lt2>
+      <a:accent1>
+        <a:srgbClr val="4F81BD"/>
+      </a:accent1>
+      <a:accent2>
+        <a:srgbClr val="C0504D"/>
+      </a:accent2>
+      <a:accent3>
+        <a:srgbClr val="9BBB59"/>
+      </a:accent3>
+      <a:accent4>
+        <a:srgbClr val="8064A2"/>
+      </a:accent4>
+      <a:accent5>
+        <a:srgbClr val="4BACC6"/>
+      </a:accent5>
+      <a:accent6>
+        <a:srgbClr val="F79646"/>
+      </a:accent6>
+      <a:hlink>
+        <a:srgbClr val="0000FF"/>
+      </a:hlink>
+      <a:folHlink>
+        <a:srgbClr val="800080"/>
+      </a:folHlink>
+    </a:clrScheme>
+    <a:fontScheme name="Office">
+      <a:majorFont>
+        <a:latin typeface="Calibri"/>
+        <a:ea typeface=""/>
+        <a:cs typeface=""/>
+        <a:font script="Jpan" typeface="ＭＳ Ｐゴシック"/>
+        <a:font script="Hang" typeface="맑은 고딕"/>
+        <a:font script="Hans" typeface="宋体"/>
+        <a:font script="Hant" typeface="新細明體"/>
+        <a:font script="Arab" typeface="Times New Roman"/>
+        <a:font script="Hebr" typeface="Times New Roman"/>
+        <a:font script="Thai" typeface="Angsana New"/>
+        <a:font script="Ethi" typeface="Nyala"/>
+        <a:font script="Beng" typeface="Vrinda"/>
+        <a:font script="Gujr" typeface="Shruti"/>
+        <a:font script="Khmr" typeface="MoolBoran"/>
+        <a:font script="Knda" typeface="Tunga"/>
+        <a:font script="Guru" typeface="Raavi"/>
+        <a:font script="Cans" typeface="Euphemia"/>
+        <a:font script="Cher" typeface="Plantagenet Cherokee"/>
+        <a:font script="Yiii" typeface="Microsoft Yi Baiti"/>
+        <a:font script="Tibt" typeface="Microsoft Himalaya"/>
+        <a:font script="Thaa" typeface="MV Boli"/>
+        <a:font script="Deva" typeface="Mangal"/>
+        <a:font script="Telu" typeface="Gautami"/>
+        <a:font script="Taml" typeface="Latha"/>
+        <a:font script="Syrc" typeface="Estrangelo Edessa"/>
+        <a:font script="Orya" typeface="Kalinga"/>
+        <a:font script="Mlym" typeface="Kartika"/>
+        <a:font script="Laoo" typeface="DokChampa"/>
+        <a:font script="Sinh" typeface="Iskoola Pota"/>
+        <a:font script="Mong" typeface="Mongolian Baiti"/>
+        <a:font script="Viet" typeface="Times New Roman"/>
+        <a:font script="Uigh" typeface="Microsoft Uighur"/>
+        <a:font script="Geor" typeface="Sylfaen"/>
+      </a:majorFont>
+      <a:minorFont>
+        <a:latin typeface="Calibri"/>
+        <a:ea typeface=""/>
+        <a:cs typeface=""/>
+        <a:font script="Jpan" typeface="ＭＳ Ｐゴシック"/>
+        <a:font script="Hang" typeface="맑은 고딕"/>
+        <a:font script="Hans" typeface="宋体"/>
+        <a:font script="Hant" typeface="新細明體"/>
+        <a:font script="Arab" typeface="Arial"/>
+        <a:font script="Hebr" typeface="Arial"/>
+        <a:font script="Thai" typeface="Cordia New"/>
+        <a:font script="Ethi" typeface="Nyala"/>
+        <a:font script="Beng" typeface="Vrinda"/>
+        <a:font script="Gujr" typeface="Shruti"/>
+        <a:font script="Khmr" typeface="DaunPenh"/>
+        <a:font script="Knda" typeface="Tunga"/>
+        <a:font script="Guru" typeface="Raavi"/>
+        <a:font script="Cans" typeface="Euphemia"/>
+        <a:font script="Cher" typeface="Plantagenet Cherokee"/>
+        <a:font script="Yiii" typeface="Microsoft Yi Baiti"/>
+        <a:font script="Tibt" typeface="Microsoft Himalaya"/>
+        <a:font script="Thaa" typeface="MV Boli"/>
+        <a:font script="Deva" typeface="Mangal"/>
+        <a:font script="Telu" typeface="Gautami"/>
+        <a:font script="Taml" typeface="Latha"/>
+        <a:font script="Syrc" typeface="Estrangelo Edessa"/>
+        <a:font script="Orya" typeface="Kalinga"/>
+        <a:font script="Mlym" typeface="Kartika"/>
+        <a:font script="Laoo" typeface="DokChampa"/>
+        <a:font script="Sinh" typeface="Iskoola Pota"/>
+        <a:font script="Mong" typeface="Mongolian Baiti"/>
+        <a:font script="Viet" typeface="Arial"/>
+        <a:font script="Uigh" typeface="Microsoft Uighur"/>
+        <a:font script="Geor" typeface="Sylfaen"/>
+      </a:minorFont>
+    </a:fontScheme>
+    <a:fmtScheme name="Office">
+      <a:fillStyleLst>
+        <a:solidFill>
+          <a:schemeClr val="phClr"/>
+        </a:solidFill>
+        <a:gradFill rotWithShape="1">
+          <a:gsLst>
+            <a:gs pos="0">
+              <a:schemeClr val="phClr">
+                <a:tint val="50000"/>
+                <a:satMod val="300000"/>
+              </a:schemeClr>
+            </a:gs>
+            <a:gs pos="35000">
+              <a:schemeClr val="phClr">
+                <a:tint val="37000"/>
+                <a:satMod val="300000"/>
+              </a:schemeClr>
+            </a:gs>
+            <a:gs pos="100000">
+              <a:schemeClr val="phClr">
+                <a:tint val="15000"/>
+                <a:satMod val="350000"/>
+              </a:schemeClr>
+            </a:gs>
+          </a:gsLst>
+          <a:lin ang="16200000" scaled="1"/>
+        </a:gradFill>
+        <a:gradFill rotWithShape="1">
+          <a:gsLst>
+            <a:gs pos="0">
+              <a:schemeClr val="phClr">
+                <a:tint val="100000"/>
+                <a:shade val="100000"/>
+                <a:satMod val="130000"/>
+              </a:schemeClr>
+            </a:gs>
+            <a:gs pos="100000">
+              <a:schemeClr val="phClr">
+                <a:tint val="50000"/>
+                <a:shade val="100000"/>
+                <a:satMod val="350000"/>
+              </a:schemeClr>
+            </a:gs>
+          </a:gsLst>
+          <a:lin ang="16200000" scaled="0"/>
+        </a:gradFill>
+      </a:fillStyleLst>
+      <a:lnStyleLst>
+        <a:ln w="9525" cap="flat" cmpd="sng" algn="ctr">
+          <a:solidFill>
+            <a:schemeClr val="phClr">
+              <a:shade val="95000"/>
+              <a:satMod val="105000"/>
+            </a:schemeClr>
+          </a:solidFill>
+          <a:prstDash val="solid"/>
+        </a:ln>
+        <a:ln w="25400" cap="flat" cmpd="sng" algn="ctr">
+          <a:solidFill>
+            <a:schemeClr val="phClr"/>
+          </a:solidFill>
+          <a:prstDash val="solid"/>
+        </a:ln>
+        <a:ln w="38100" cap="flat" cmpd="sng" algn="ctr">
+          <a:solidFill>
+            <a:schemeClr val="phClr"/>
+          </a:solidFill>
+          <a:prstDash val="solid"/>
+        </a:ln>
+      </a:lnStyleLst>
+      <a:effectStyleLst>
+        <a:effectStyle>
+          <a:effectLst>
+            <a:outerShdw blurRad="40000" dist="20000" dir="5400000" rotWithShape="0">
+              <a:srgbClr val="000000">
+                <a:alpha val="38000"/>
+              </a:srgbClr>
+            </a:outerShdw>
+          </a:effectLst>
+        </a:effectStyle>
+        <a:effectStyle>
+          <a:effectLst>
+            <a:outerShdw blurRad="40000" dist="23000" dir="5400000" rotWithShape="0">
+              <a:srgbClr val="000000">
+                <a:alpha val="35000"/>
+              </a:srgbClr>
+            </a:outerShdw>
+          </a:effectLst>
+        </a:effectStyle>
+        <a:effectStyle>
+          <a:effectLst>
+            <a:outerShdw blurRad="40000" dist="23000" dir="5400000" rotWithShape="0">
+              <a:srgbClr val="000000">
+                <a:alpha val="35000"/>
+              </a:srgbClr>
+            </a:outerShdw>
+          </a:effectLst>
+          <a:scene3d>
+            <a:camera prst="orthographicFront">
+              <a:rot lat="0" lon="0" rev="0"/>
+            </a:camera>
+            <a:lightRig rig="threePt" dir="t">
+              <a:rot lat="0" lon="0" rev="1200000"/>
+            </a:lightRig>
+          </a:scene3d>
+          <a:sp3d>
+            <a:bevelT w="63500" h="25400"/>
+          </a:sp3d>
+        </a:effectStyle>
+      </a:effectStyleLst>
+      <a:bgFillStyleLst>
+        <a:solidFill>
+          <a:schemeClr val="phClr"/>
+        </a:solidFill>
+        <a:gradFill rotWithShape="1">
+          <a:gsLst>
+            <a:gs pos="0">
+              <a:schemeClr val="phClr">
+                <a:tint val="40000"/>
+                <a:satMod val="350000"/>
+              </a:schemeClr>
+            </a:gs>
+            <a:gs pos="40000">
+              <a:schemeClr val="phClr">
+                <a:tint val="45000"/>
+                <a:shade val="99000"/>
+                <a:satMod val="350000"/>
+              </a:schemeClr>
+            </a:gs>
+            <a:gs pos="100000">
+              <a:schemeClr val="phClr">
+                <a:shade val="20000"/>
+                <a:satMod val="255000"/>
+              </a:schemeClr>
+            </a:gs>
+          </a:gsLst>
+          <a:path path="circle">
+            <a:fillToRect l="50000" t="-80000" r="50000" b="180000"/>
+          </a:path>
+        </a:gradFill>
+        <a:gradFill rotWithShape="1">
+          <a:gsLst>
+            <a:gs pos="0">
+              <a:schemeClr val="phClr">
+                <a:tint val="80000"/>
+                <a:satMod val="300000"/>
+              </a:schemeClr>
+            </a:gs>
+            <a:gs pos="100000">
+              <a:schemeClr val="phClr">
+                <a:shade val="30000"/>
+                <a:satMod val="200000"/>
+              </a:schemeClr>
+            </a:gs>
+          </a:gsLst>
+          <a:path path="circle">
+            <a:fillToRect l="50000" t="50000" r="50000" b="50000"/>
+          </a:path>
+        </a:gradFill>
+      </a:bgFillStyleLst>
+    </a:fmtScheme>
+  </a:themeElements>
+  <a:objectDefaults>
+    <a:spDef>
+      <a:spPr/>
+      <a:bodyPr/>
+      <a:lstStyle/>
+      <a:style>
+        <a:lnRef idx="1">
+          <a:schemeClr val="accent1"/>
+        </a:lnRef>
+        <a:fillRef idx="3">
+          <a:schemeClr val="accent1"/>
+        </a:fillRef>
+        <a:effectRef idx="2">
+          <a:schemeClr val="accent1"/>
+        </a:effectRef>
+        <a:fontRef idx="minor">
+          <a:schemeClr val="lt1"/>
+        </a:fontRef>
+      </a:style>
+    </a:spDef>
+    <a:lnDef>
+      <a:spPr/>
+      <a:bodyPr/>
+      <a:lstStyle/>
+      <a:style>
+        <a:lnRef idx="2">
+          <a:schemeClr val="accent1"/>
+        </a:lnRef>
+        <a:fillRef idx="0">
+          <a:schemeClr val="accent1"/>
+        </a:fillRef>
+        <a:effectRef idx="1">
+          <a:schemeClr val="accent1"/>
+        </a:effectRef>
+        <a:fontRef idx="minor">
+          <a:schemeClr val="tx1"/>
+        </a:fontRef>
+      </a:style>
+    </a:lnDef>
+  </a:objectDefaults>
+  <a:extraClrSchemeLst/>
+</a:theme>
 </file>
</xml_diff>

<commit_message>
feat: release v3.0.0 with 15 layout primitives and 6-scenario generic decoupling
- Expanded layout primitives from 10 to 15 (added standard_table, data_chart with native vector CategoryChartData, content_columns, keynote_quote, process_flow)
- Overhauled cognitive planner to support 6 universal scenarios (strategy, tech architecture, pitch deck, resume, education/training, general informative) with zero domain hardcoding
- Decoupled content and semantic auditors for scenario-aware qualitative/quantitative evidence weighting and expanded rhetorical taxonomy
- Documented complete 15-layout JSON schemas in SKILL.md for direct AI Agent blueprint composition
- Updated CLI demo, unit tests (15/15 passing), and documentation across README and CHANGELOG
</commit_message>
<xml_diff>
--- a/output/presentation.pptx
+++ b/output/presentation.pptx
@@ -11,6 +11,8 @@
     <p:sldId id="259" r:id="rId11"/>
     <p:sldId id="260" r:id="rId12"/>
     <p:sldId id="261" r:id="rId13"/>
+    <p:sldId id="262" r:id="rId14"/>
+    <p:sldId id="263" r:id="rId15"/>
   </p:sldIdLst>
   <p:sldSz cx="12191695" cy="6858000" type="screen4x3"/>
   <p:notesSz cx="6858000" cy="9144000"/>
@@ -110,6 +112,238 @@
     </a:lvl9pPr>
   </p:defaultTextStyle>
 </p:presentation>
+</file>
+
+<file path=ppt/charts/chart1.xml><?xml version="1.0" encoding="utf-8"?>
+<c:chartSpace xmlns:c="http://schemas.openxmlformats.org/drawingml/2006/chart" xmlns:a="http://schemas.openxmlformats.org/drawingml/2006/main" xmlns:r="http://schemas.openxmlformats.org/officeDocument/2006/relationships">
+  <c:date1904 val="0"/>
+  <c:chart>
+    <c:autoTitleDeleted val="0"/>
+    <c:plotArea>
+      <c:barChart>
+        <c:barDir val="col"/>
+        <c:grouping val="clustered"/>
+        <c:ser>
+          <c:idx val="0"/>
+          <c:order val="0"/>
+          <c:tx>
+            <c:strRef>
+              <c:f>Sheet1!$B$1</c:f>
+              <c:strCache>
+                <c:ptCount val="1"/>
+                <c:pt idx="0">
+                  <c:v>被动对话 LLM</c:v>
+                </c:pt>
+              </c:strCache>
+            </c:strRef>
+          </c:tx>
+          <c:cat>
+            <c:strRef>
+              <c:f>Sheet1!$A$2:$A$5</c:f>
+              <c:strCache>
+                <c:ptCount val="4"/>
+                <c:pt idx="0">
+                  <c:v>意图对齐</c:v>
+                </c:pt>
+                <c:pt idx="1">
+                  <c:v>长程规划</c:v>
+                </c:pt>
+                <c:pt idx="2">
+                  <c:v>沙箱工具调用</c:v>
+                </c:pt>
+                <c:pt idx="3">
+                  <c:v>异常自愈</c:v>
+                </c:pt>
+              </c:strCache>
+            </c:strRef>
+          </c:cat>
+          <c:val>
+            <c:numRef>
+              <c:f>Sheet1!$B$2:$B$5</c:f>
+              <c:numCache>
+                <c:formatCode>General</c:formatCode>
+                <c:ptCount val="4"/>
+                <c:pt idx="0">
+                  <c:v>65.0</c:v>
+                </c:pt>
+                <c:pt idx="1">
+                  <c:v>42.0</c:v>
+                </c:pt>
+                <c:pt idx="2">
+                  <c:v>30.0</c:v>
+                </c:pt>
+                <c:pt idx="3">
+                  <c:v>25.0</c:v>
+                </c:pt>
+              </c:numCache>
+            </c:numRef>
+          </c:val>
+        </c:ser>
+        <c:ser>
+          <c:idx val="1"/>
+          <c:order val="1"/>
+          <c:tx>
+            <c:strRef>
+              <c:f>Sheet1!$C$1</c:f>
+              <c:strCache>
+                <c:ptCount val="1"/>
+                <c:pt idx="0">
+                  <c:v>传统工作流 RPA</c:v>
+                </c:pt>
+              </c:strCache>
+            </c:strRef>
+          </c:tx>
+          <c:cat>
+            <c:strRef>
+              <c:f>Sheet1!$A$2:$A$5</c:f>
+              <c:strCache>
+                <c:ptCount val="4"/>
+                <c:pt idx="0">
+                  <c:v>意图对齐</c:v>
+                </c:pt>
+                <c:pt idx="1">
+                  <c:v>长程规划</c:v>
+                </c:pt>
+                <c:pt idx="2">
+                  <c:v>沙箱工具调用</c:v>
+                </c:pt>
+                <c:pt idx="3">
+                  <c:v>异常自愈</c:v>
+                </c:pt>
+              </c:strCache>
+            </c:strRef>
+          </c:cat>
+          <c:val>
+            <c:numRef>
+              <c:f>Sheet1!$C$2:$C$5</c:f>
+              <c:numCache>
+                <c:formatCode>General</c:formatCode>
+                <c:ptCount val="4"/>
+                <c:pt idx="0">
+                  <c:v>40.0</c:v>
+                </c:pt>
+                <c:pt idx="1">
+                  <c:v>55.0</c:v>
+                </c:pt>
+                <c:pt idx="2">
+                  <c:v>70.0</c:v>
+                </c:pt>
+                <c:pt idx="3">
+                  <c:v>35.0</c:v>
+                </c:pt>
+              </c:numCache>
+            </c:numRef>
+          </c:val>
+        </c:ser>
+        <c:ser>
+          <c:idx val="2"/>
+          <c:order val="2"/>
+          <c:tx>
+            <c:strRef>
+              <c:f>Sheet1!$D$1</c:f>
+              <c:strCache>
+                <c:ptCount val="1"/>
+                <c:pt idx="0">
+                  <c:v>Agentic AI 架构</c:v>
+                </c:pt>
+              </c:strCache>
+            </c:strRef>
+          </c:tx>
+          <c:cat>
+            <c:strRef>
+              <c:f>Sheet1!$A$2:$A$5</c:f>
+              <c:strCache>
+                <c:ptCount val="4"/>
+                <c:pt idx="0">
+                  <c:v>意图对齐</c:v>
+                </c:pt>
+                <c:pt idx="1">
+                  <c:v>长程规划</c:v>
+                </c:pt>
+                <c:pt idx="2">
+                  <c:v>沙箱工具调用</c:v>
+                </c:pt>
+                <c:pt idx="3">
+                  <c:v>异常自愈</c:v>
+                </c:pt>
+              </c:strCache>
+            </c:strRef>
+          </c:cat>
+          <c:val>
+            <c:numRef>
+              <c:f>Sheet1!$D$2:$D$5</c:f>
+              <c:numCache>
+                <c:formatCode>General</c:formatCode>
+                <c:ptCount val="4"/>
+                <c:pt idx="0">
+                  <c:v>95.0</c:v>
+                </c:pt>
+                <c:pt idx="1">
+                  <c:v>92.0</c:v>
+                </c:pt>
+                <c:pt idx="2">
+                  <c:v>94.0</c:v>
+                </c:pt>
+                <c:pt idx="3">
+                  <c:v>88.0</c:v>
+                </c:pt>
+              </c:numCache>
+            </c:numRef>
+          </c:val>
+        </c:ser>
+        <c:axId val="-2068027336"/>
+        <c:axId val="-2113994440"/>
+      </c:barChart>
+      <c:catAx>
+        <c:axId val="-2068027336"/>
+        <c:scaling>
+          <c:orientation val="minMax"/>
+        </c:scaling>
+        <c:delete val="0"/>
+        <c:axPos val="b"/>
+        <c:majorTickMark val="out"/>
+        <c:minorTickMark val="none"/>
+        <c:tickLblPos val="nextTo"/>
+        <c:crossAx val="-2113994440"/>
+        <c:crosses val="autoZero"/>
+        <c:auto val="1"/>
+        <c:lblAlgn val="ctr"/>
+        <c:lblOffset val="100"/>
+        <c:noMultiLvlLbl val="0"/>
+      </c:catAx>
+      <c:valAx>
+        <c:axId val="-2113994440"/>
+        <c:scaling/>
+        <c:delete val="0"/>
+        <c:axPos val="l"/>
+        <c:majorGridlines/>
+        <c:majorTickMark val="out"/>
+        <c:minorTickMark val="none"/>
+        <c:tickLblPos val="nextTo"/>
+        <c:crossAx val="-2068027336"/>
+        <c:crosses val="autoZero"/>
+      </c:valAx>
+    </c:plotArea>
+    <c:legend>
+      <c:legendPos val="t"/>
+      <c:overlay val="0"/>
+    </c:legend>
+    <c:dispBlanksAs val="gap"/>
+  </c:chart>
+  <c:txPr>
+    <a:bodyPr/>
+    <a:lstStyle/>
+    <a:p>
+      <a:pPr>
+        <a:defRPr sz="1800"/>
+      </a:pPr>
+      <a:endParaRPr lang="en-US"/>
+    </a:p>
+  </c:txPr>
+  <c:externalData r:id="rId1">
+    <c:autoUpdate val="0"/>
+  </c:externalData>
+</c:chartSpace>
 </file>
 
 <file path=ppt/notesMasters/notesMaster1.xml><?xml version="1.0" encoding="utf-8"?>
@@ -867,22 +1101,22 @@
           <a:lstStyle/>
           <a:p>
             <a:r>
-              <a:t>【叙事阶段 / Arc】PROGRESSION</a:t>
-            </a:r>
-          </a:p>
-          <a:p>
-            <a:r>
-              <a:t>【单页使命 / Mission】给出低风险渐进式落地路径，打消听众对迁移风险的顾虑</a:t>
-            </a:r>
-          </a:p>
-          <a:p>
-            <a:r>
-              <a:t>【承上启下 / Transition】【落地】为确保业务平滑过渡，推行‘试点-建设-推广-生态’四步走路线</a:t>
-            </a:r>
-          </a:p>
-          <a:p>
-            <a:r>
-              <a:t>【核心论据 / Evidence】Q1 试点验证，Q2 平台就绪，Q3 规模推广，Q4 自主进化闭环</a:t>
+              <a:t>【叙事阶段 / Arc】EVIDENCE</a:t>
+            </a:r>
+          </a:p>
+          <a:p>
+            <a:r>
+              <a:t>【单页使命 / Mission】用原生矢量数据图表横向对齐关键业务指标与ROI演进曲线</a:t>
+            </a:r>
+          </a:p>
+          <a:p>
+            <a:r>
+              <a:t>【承上启下 / Transition】【验证】从横向基准实测来看，自主协同集群在各核心维度全面领跑</a:t>
+            </a:r>
+          </a:p>
+          <a:p>
+            <a:r>
+              <a:t>【核心论据 / Evidence】Agentic 方案实现 94.8% 自主完成率，交付耗时从 450s 降至 45s</a:t>
             </a:r>
           </a:p>
         </p:txBody>
@@ -908,6 +1142,176 @@
 </file>
 
 <file path=ppt/notesSlides/notesSlide6.xml><?xml version="1.0" encoding="utf-8"?>
+<p:notes xmlns:a="http://schemas.openxmlformats.org/drawingml/2006/main" xmlns:p="http://schemas.openxmlformats.org/presentationml/2006/main" xmlns:r="http://schemas.openxmlformats.org/officeDocument/2006/relationships">
+  <p:cSld>
+    <p:spTree>
+      <p:nvGrpSpPr>
+        <p:cNvPr id="1" name=""/>
+        <p:cNvGrpSpPr/>
+        <p:nvPr/>
+      </p:nvGrpSpPr>
+      <p:grpSpPr>
+        <a:xfrm>
+          <a:off x="0" y="0"/>
+          <a:ext cx="0" cy="0"/>
+          <a:chOff x="0" y="0"/>
+          <a:chExt cx="0" cy="0"/>
+        </a:xfrm>
+      </p:grpSpPr>
+      <p:sp>
+        <p:nvSpPr>
+          <p:cNvPr id="2" name="Slide Image Placeholder 1"/>
+          <p:cNvSpPr>
+            <a:spLocks noGrp="1"/>
+          </p:cNvSpPr>
+          <p:nvPr>
+            <p:ph type="sldImg" idx="2"/>
+          </p:nvPr>
+        </p:nvSpPr>
+        <p:spPr/>
+      </p:sp>
+      <p:sp>
+        <p:nvSpPr>
+          <p:cNvPr id="3" name="Notes Placeholder 2"/>
+          <p:cNvSpPr>
+            <a:spLocks noGrp="1"/>
+          </p:cNvSpPr>
+          <p:nvPr>
+            <p:ph type="body" idx="3" sz="quarter"/>
+          </p:nvPr>
+        </p:nvSpPr>
+        <p:spPr/>
+        <p:txBody>
+          <a:bodyPr/>
+          <a:lstStyle/>
+          <a:p>
+            <a:r>
+              <a:t>【叙事阶段 / Arc】EVIDENCE</a:t>
+            </a:r>
+          </a:p>
+          <a:p>
+            <a:r>
+              <a:t>【单页使命 / Mission】以结构化规整矩阵清晰对照核心能力成熟度与落地保障</a:t>
+            </a:r>
+          </a:p>
+          <a:p>
+            <a:r>
+              <a:t>【承上启下 / Transition】【细化】进一步通过功能与合规成熟度矩阵，锁定各组件能力层级</a:t>
+            </a:r>
+          </a:p>
+          <a:p>
+            <a:r>
+              <a:t>【核心论据 / Evidence】100% 覆盖安全隔离与审计合规要求，故障自愈恢复耗时 &lt;10s</a:t>
+            </a:r>
+          </a:p>
+        </p:txBody>
+      </p:sp>
+      <p:sp>
+        <p:nvSpPr>
+          <p:cNvPr id="4" name="Slide Number Placeholder 3"/>
+          <p:cNvSpPr>
+            <a:spLocks noGrp="1"/>
+          </p:cNvSpPr>
+          <p:nvPr>
+            <p:ph type="sldNum" idx="5" sz="quarter"/>
+          </p:nvPr>
+        </p:nvSpPr>
+        <p:spPr/>
+      </p:sp>
+    </p:spTree>
+  </p:cSld>
+  <p:clrMapOvr>
+    <a:masterClrMapping/>
+  </p:clrMapOvr>
+</p:notes>
+</file>
+
+<file path=ppt/notesSlides/notesSlide7.xml><?xml version="1.0" encoding="utf-8"?>
+<p:notes xmlns:a="http://schemas.openxmlformats.org/drawingml/2006/main" xmlns:p="http://schemas.openxmlformats.org/presentationml/2006/main" xmlns:r="http://schemas.openxmlformats.org/officeDocument/2006/relationships">
+  <p:cSld>
+    <p:spTree>
+      <p:nvGrpSpPr>
+        <p:cNvPr id="1" name=""/>
+        <p:cNvGrpSpPr/>
+        <p:nvPr/>
+      </p:nvGrpSpPr>
+      <p:grpSpPr>
+        <a:xfrm>
+          <a:off x="0" y="0"/>
+          <a:ext cx="0" cy="0"/>
+          <a:chOff x="0" y="0"/>
+          <a:chExt cx="0" cy="0"/>
+        </a:xfrm>
+      </p:grpSpPr>
+      <p:sp>
+        <p:nvSpPr>
+          <p:cNvPr id="2" name="Slide Image Placeholder 1"/>
+          <p:cNvSpPr>
+            <a:spLocks noGrp="1"/>
+          </p:cNvSpPr>
+          <p:nvPr>
+            <p:ph type="sldImg" idx="2"/>
+          </p:nvPr>
+        </p:nvSpPr>
+        <p:spPr/>
+      </p:sp>
+      <p:sp>
+        <p:nvSpPr>
+          <p:cNvPr id="3" name="Notes Placeholder 2"/>
+          <p:cNvSpPr>
+            <a:spLocks noGrp="1"/>
+          </p:cNvSpPr>
+          <p:nvPr>
+            <p:ph type="body" idx="3" sz="quarter"/>
+          </p:nvPr>
+        </p:nvSpPr>
+        <p:spPr/>
+        <p:txBody>
+          <a:bodyPr/>
+          <a:lstStyle/>
+          <a:p>
+            <a:r>
+              <a:t>【叙事阶段 / Arc】PROGRESSION</a:t>
+            </a:r>
+          </a:p>
+          <a:p>
+            <a:r>
+              <a:t>【单页使命 / Mission】给出低风险渐进式落地路径，打消听众对迁移风险的顾虑</a:t>
+            </a:r>
+          </a:p>
+          <a:p>
+            <a:r>
+              <a:t>【承上启下 / Transition】【落地】为确保业务平滑过渡，推行‘试点-建设-推广-生态’四步走路线</a:t>
+            </a:r>
+          </a:p>
+          <a:p>
+            <a:r>
+              <a:t>【核心论据 / Evidence】Q1 试点验证，Q2 平台就绪，Q3 规模推广，Q4 自主进化闭环</a:t>
+            </a:r>
+          </a:p>
+        </p:txBody>
+      </p:sp>
+      <p:sp>
+        <p:nvSpPr>
+          <p:cNvPr id="4" name="Slide Number Placeholder 3"/>
+          <p:cNvSpPr>
+            <a:spLocks noGrp="1"/>
+          </p:cNvSpPr>
+          <p:nvPr>
+            <p:ph type="sldNum" idx="5" sz="quarter"/>
+          </p:nvPr>
+        </p:nvSpPr>
+        <p:spPr/>
+      </p:sp>
+    </p:spTree>
+  </p:cSld>
+  <p:clrMapOvr>
+    <a:masterClrMapping/>
+  </p:clrMapOvr>
+</p:notes>
+</file>
+
+<file path=ppt/notesSlides/notesSlide8.xml><?xml version="1.0" encoding="utf-8"?>
 <p:notes xmlns:a="http://schemas.openxmlformats.org/drawingml/2006/main" xmlns:p="http://schemas.openxmlformats.org/presentationml/2006/main" xmlns:r="http://schemas.openxmlformats.org/officeDocument/2006/relationships">
   <p:cSld>
     <p:spTree>
@@ -6795,6 +7199,1051 @@
                 </a:solidFill>
                 <a:latin typeface="PingFang SC, Inter, sans-serif"/>
               </a:rPr>
+              <a:t>EVIDENCE</a:t>
+            </a:r>
+          </a:p>
+        </p:txBody>
+      </p:sp>
+      <p:sp>
+        <p:nvSpPr>
+          <p:cNvPr id="4" name="TextBox 3"/>
+          <p:cNvSpPr txBox="1"/>
+          <p:nvPr/>
+        </p:nvSpPr>
+        <p:spPr>
+          <a:xfrm>
+            <a:off x="731520" y="1069848"/>
+            <a:ext cx="10698480" cy="1188720"/>
+          </a:xfrm>
+          <a:prstGeom prst="rect">
+            <a:avLst/>
+          </a:prstGeom>
+          <a:noFill/>
+        </p:spPr>
+        <p:txBody>
+          <a:bodyPr wrap="square" lIns="0" tIns="0" rIns="0" bIns="0">
+            <a:spAutoFit/>
+          </a:bodyPr>
+          <a:lstStyle/>
+          <a:p>
+            <a:pPr>
+              <a:spcAft>
+                <a:spcPts val="400"/>
+              </a:spcAft>
+            </a:pPr>
+            <a:r>
+              <a:rPr sz="3400" b="1">
+                <a:solidFill>
+                  <a:srgbClr val="0F172A"/>
+                </a:solidFill>
+                <a:latin typeface="PingFang SC, Inter, sans-serif"/>
+              </a:rPr>
+              <a:t>评测：全场景端到端自主完成率与耗时显著优于行业基准</a:t>
+            </a:r>
+          </a:p>
+          <a:p>
+            <a:r>
+              <a:rPr sz="1800">
+                <a:solidFill>
+                  <a:srgbClr val="475569"/>
+                </a:solidFill>
+                <a:latin typeface="PingFang SC, Inter, sans-serif"/>
+              </a:rPr>
+              <a:t>针对生产环境四大典型场景的自动化程度与人机协同综合评分（满分100）</a:t>
+            </a:r>
+          </a:p>
+        </p:txBody>
+      </p:sp>
+      <p:graphicFrame>
+        <p:nvGraphicFramePr>
+          <p:cNvPr id="5" name="Chart 4"/>
+          <p:cNvGraphicFramePr>
+            <a:graphicFrameLocks noGrp="1"/>
+          </p:cNvGraphicFramePr>
+          <p:nvPr/>
+        </p:nvGraphicFramePr>
+        <p:xfrm>
+          <a:off x="731520" y="2011680"/>
+          <a:ext cx="7315200" cy="4297680"/>
+        </p:xfrm>
+        <a:graphic>
+          <a:graphicData uri="http://schemas.openxmlformats.org/drawingml/2006/chart">
+            <c:chart xmlns:c="http://schemas.openxmlformats.org/drawingml/2006/chart" r:id="rId2"/>
+          </a:graphicData>
+        </a:graphic>
+      </p:graphicFrame>
+      <p:sp>
+        <p:nvSpPr>
+          <p:cNvPr id="6" name="Rounded Rectangle 5"/>
+          <p:cNvSpPr/>
+          <p:nvPr/>
+        </p:nvSpPr>
+        <p:spPr>
+          <a:xfrm>
+            <a:off x="8321040" y="2011680"/>
+            <a:ext cx="3139135" cy="4297680"/>
+          </a:xfrm>
+          <a:prstGeom prst="roundRect">
+            <a:avLst/>
+          </a:prstGeom>
+          <a:solidFill>
+            <a:srgbClr val="FFFFFF"/>
+          </a:solidFill>
+          <a:ln w="19050">
+            <a:solidFill>
+              <a:srgbClr val="2563EB"/>
+            </a:solidFill>
+          </a:ln>
+        </p:spPr>
+        <p:style>
+          <a:lnRef idx="1">
+            <a:schemeClr val="accent1"/>
+          </a:lnRef>
+          <a:fillRef idx="3">
+            <a:schemeClr val="accent1"/>
+          </a:fillRef>
+          <a:effectRef idx="2">
+            <a:schemeClr val="accent1"/>
+          </a:effectRef>
+          <a:fontRef idx="minor">
+            <a:schemeClr val="lt1"/>
+          </a:fontRef>
+        </p:style>
+        <p:txBody>
+          <a:bodyPr rtlCol="0" anchor="ctr" wrap="square" lIns="182880" tIns="182880"/>
+          <a:lstStyle/>
+          <a:p>
+            <a:pPr algn="ctr"/>
+            <a:r>
+              <a:rPr b="1" sz="1000">
+                <a:solidFill>
+                  <a:srgbClr val="2563EB"/>
+                </a:solidFill>
+              </a:rPr>
+              <a:t>KEY TAKEAWAY</a:t>
+            </a:r>
+          </a:p>
+          <a:p>
+            <a:pPr>
+              <a:spcBef>
+                <a:spcPts val="800"/>
+              </a:spcBef>
+            </a:pPr>
+            <a:r>
+              <a:rPr b="1" sz="1400">
+                <a:solidFill>
+                  <a:srgbClr val="0F172A"/>
+                </a:solidFill>
+              </a:rPr>
+              <a:t>核心数据洞察与结论</a:t>
+            </a:r>
+          </a:p>
+          <a:p>
+            <a:pPr>
+              <a:spcBef>
+                <a:spcPts val="1000"/>
+              </a:spcBef>
+            </a:pPr>
+            <a:r>
+              <a:rPr sz="1200">
+                <a:solidFill>
+                  <a:srgbClr val="475569"/>
+                </a:solidFill>
+              </a:rPr>
+              <a:t>Agentic 方案实现 94.8% 自主完成率，交付耗时从 450s 降至 45s</a:t>
+            </a:r>
+          </a:p>
+        </p:txBody>
+      </p:sp>
+    </p:spTree>
+  </p:cSld>
+  <p:clrMapOvr>
+    <a:masterClrMapping/>
+  </p:clrMapOvr>
+</p:sld>
+</file>
+
+<file path=ppt/slides/slide6.xml><?xml version="1.0" encoding="utf-8"?>
+<p:sld xmlns:a="http://schemas.openxmlformats.org/drawingml/2006/main" xmlns:p="http://schemas.openxmlformats.org/presentationml/2006/main" xmlns:r="http://schemas.openxmlformats.org/officeDocument/2006/relationships">
+  <p:cSld>
+    <p:spTree>
+      <p:nvGrpSpPr>
+        <p:cNvPr id="1" name=""/>
+        <p:cNvGrpSpPr/>
+        <p:nvPr/>
+      </p:nvGrpSpPr>
+      <p:grpSpPr/>
+      <p:sp>
+        <p:nvSpPr>
+          <p:cNvPr id="2" name="Rectangle 1"/>
+          <p:cNvSpPr/>
+          <p:nvPr/>
+        </p:nvSpPr>
+        <p:spPr>
+          <a:xfrm>
+            <a:off x="0" y="0"/>
+            <a:ext cx="12191695" cy="6858000"/>
+          </a:xfrm>
+          <a:prstGeom prst="rect">
+            <a:avLst/>
+          </a:prstGeom>
+          <a:solidFill>
+            <a:srgbClr val="F8FAFC"/>
+          </a:solidFill>
+          <a:ln>
+            <a:noFill/>
+          </a:ln>
+        </p:spPr>
+        <p:style>
+          <a:lnRef idx="1">
+            <a:schemeClr val="accent1"/>
+          </a:lnRef>
+          <a:fillRef idx="3">
+            <a:schemeClr val="accent1"/>
+          </a:fillRef>
+          <a:effectRef idx="2">
+            <a:schemeClr val="accent1"/>
+          </a:effectRef>
+          <a:fontRef idx="minor">
+            <a:schemeClr val="lt1"/>
+          </a:fontRef>
+        </p:style>
+        <p:txBody>
+          <a:bodyPr rtlCol="0" anchor="ctr"/>
+          <a:lstStyle/>
+          <a:p>
+            <a:pPr algn="ctr"/>
+          </a:p>
+        </p:txBody>
+      </p:sp>
+      <p:sp>
+        <p:nvSpPr>
+          <p:cNvPr id="3" name="Rounded Rectangle 2"/>
+          <p:cNvSpPr/>
+          <p:nvPr/>
+        </p:nvSpPr>
+        <p:spPr>
+          <a:xfrm>
+            <a:off x="731520" y="685800"/>
+            <a:ext cx="1645920" cy="292608"/>
+          </a:xfrm>
+          <a:prstGeom prst="roundRect">
+            <a:avLst/>
+          </a:prstGeom>
+          <a:solidFill>
+            <a:srgbClr val="F1F5F9"/>
+          </a:solidFill>
+          <a:ln w="12700">
+            <a:solidFill>
+              <a:srgbClr val="38BDF8"/>
+            </a:solidFill>
+          </a:ln>
+        </p:spPr>
+        <p:style>
+          <a:lnRef idx="1">
+            <a:schemeClr val="accent1"/>
+          </a:lnRef>
+          <a:fillRef idx="3">
+            <a:schemeClr val="accent1"/>
+          </a:fillRef>
+          <a:effectRef idx="2">
+            <a:schemeClr val="accent1"/>
+          </a:effectRef>
+          <a:fontRef idx="minor">
+            <a:schemeClr val="lt1"/>
+          </a:fontRef>
+        </p:style>
+        <p:txBody>
+          <a:bodyPr rtlCol="0" anchor="ctr" wrap="square"/>
+          <a:lstStyle/>
+          <a:p>
+            <a:pPr algn="ctr"/>
+            <a:r>
+              <a:rPr sz="1000" b="1">
+                <a:solidFill>
+                  <a:srgbClr val="2563EB"/>
+                </a:solidFill>
+                <a:latin typeface="PingFang SC, Inter, sans-serif"/>
+              </a:rPr>
+              <a:t>EVIDENCE</a:t>
+            </a:r>
+          </a:p>
+        </p:txBody>
+      </p:sp>
+      <p:sp>
+        <p:nvSpPr>
+          <p:cNvPr id="4" name="TextBox 3"/>
+          <p:cNvSpPr txBox="1"/>
+          <p:nvPr/>
+        </p:nvSpPr>
+        <p:spPr>
+          <a:xfrm>
+            <a:off x="731520" y="1069848"/>
+            <a:ext cx="10698480" cy="1188720"/>
+          </a:xfrm>
+          <a:prstGeom prst="rect">
+            <a:avLst/>
+          </a:prstGeom>
+          <a:noFill/>
+        </p:spPr>
+        <p:txBody>
+          <a:bodyPr wrap="square" lIns="0" tIns="0" rIns="0" bIns="0">
+            <a:spAutoFit/>
+          </a:bodyPr>
+          <a:lstStyle/>
+          <a:p>
+            <a:pPr>
+              <a:spcAft>
+                <a:spcPts val="400"/>
+              </a:spcAft>
+            </a:pPr>
+            <a:r>
+              <a:rPr sz="3400" b="1">
+                <a:solidFill>
+                  <a:srgbClr val="0F172A"/>
+                </a:solidFill>
+                <a:latin typeface="PingFang SC, Inter, sans-serif"/>
+              </a:rPr>
+              <a:t>规约：构建高可用、多租户、工具沙箱三位一体的落地护城河</a:t>
+            </a:r>
+          </a:p>
+          <a:p>
+            <a:r>
+              <a:rPr sz="1800">
+                <a:solidFill>
+                  <a:srgbClr val="475569"/>
+                </a:solidFill>
+                <a:latin typeface="PingFang SC, Inter, sans-serif"/>
+              </a:rPr>
+              <a:t>明确各关键模块的技术能力界限、响应延迟与可用性保障标准</a:t>
+            </a:r>
+          </a:p>
+        </p:txBody>
+      </p:sp>
+      <p:graphicFrame>
+        <p:nvGraphicFramePr>
+          <p:cNvPr id="5" name="Table 4"/>
+          <p:cNvGraphicFramePr>
+            <a:graphicFrameLocks noGrp="1"/>
+          </p:cNvGraphicFramePr>
+          <p:nvPr/>
+        </p:nvGraphicFramePr>
+        <p:xfrm>
+          <a:off x="731520" y="2011680"/>
+          <a:ext cx="10728655" cy="2743200"/>
+        </p:xfrm>
+        <a:graphic>
+          <a:graphicData uri="http://schemas.openxmlformats.org/drawingml/2006/table">
+            <a:tbl>
+              <a:tblPr firstRow="1" bandRow="1">
+                <a:tableStyleId>{5C22544A-7EE6-4342-B048-85BDC9FD1C3A}</a:tableStyleId>
+              </a:tblPr>
+              <a:tblGrid>
+                <a:gridCol w="2145731"/>
+                <a:gridCol w="2145731"/>
+                <a:gridCol w="2145731"/>
+                <a:gridCol w="2145731"/>
+                <a:gridCol w="2145731"/>
+              </a:tblGrid>
+              <a:tr h="548640">
+                <a:tc>
+                  <a:txBody>
+                    <a:bodyPr wrap="square"/>
+                    <a:lstStyle/>
+                    <a:p>
+                      <a:pPr algn="ctr"/>
+                      <a:r>
+                        <a:rPr sz="1300" b="1">
+                          <a:solidFill>
+                            <a:srgbClr val="FFFFFF"/>
+                          </a:solidFill>
+                          <a:latin typeface="PingFang SC, Inter, sans-serif"/>
+                        </a:rPr>
+                        <a:t>模块组件</a:t>
+                      </a:r>
+                    </a:p>
+                  </a:txBody>
+                  <a:tcPr>
+                    <a:solidFill>
+                      <a:srgbClr val="2563EB"/>
+                    </a:solidFill>
+                  </a:tcPr>
+                </a:tc>
+                <a:tc>
+                  <a:txBody>
+                    <a:bodyPr wrap="square"/>
+                    <a:lstStyle/>
+                    <a:p>
+                      <a:pPr algn="ctr"/>
+                      <a:r>
+                        <a:rPr sz="1300" b="1">
+                          <a:solidFill>
+                            <a:srgbClr val="FFFFFF"/>
+                          </a:solidFill>
+                          <a:latin typeface="PingFang SC, Inter, sans-serif"/>
+                        </a:rPr>
+                        <a:t>技术能力</a:t>
+                      </a:r>
+                    </a:p>
+                  </a:txBody>
+                  <a:tcPr>
+                    <a:solidFill>
+                      <a:srgbClr val="2563EB"/>
+                    </a:solidFill>
+                  </a:tcPr>
+                </a:tc>
+                <a:tc>
+                  <a:txBody>
+                    <a:bodyPr wrap="square"/>
+                    <a:lstStyle/>
+                    <a:p>
+                      <a:pPr algn="ctr"/>
+                      <a:r>
+                        <a:rPr sz="1300" b="1">
+                          <a:solidFill>
+                            <a:srgbClr val="FFFFFF"/>
+                          </a:solidFill>
+                          <a:latin typeface="PingFang SC, Inter, sans-serif"/>
+                        </a:rPr>
+                        <a:t>延迟/SLA</a:t>
+                      </a:r>
+                    </a:p>
+                  </a:txBody>
+                  <a:tcPr>
+                    <a:solidFill>
+                      <a:srgbClr val="2563EB"/>
+                    </a:solidFill>
+                  </a:tcPr>
+                </a:tc>
+                <a:tc>
+                  <a:txBody>
+                    <a:bodyPr wrap="square"/>
+                    <a:lstStyle/>
+                    <a:p>
+                      <a:pPr algn="ctr"/>
+                      <a:r>
+                        <a:rPr sz="1300" b="1">
+                          <a:solidFill>
+                            <a:srgbClr val="FFFFFF"/>
+                          </a:solidFill>
+                          <a:latin typeface="PingFang SC, Inter, sans-serif"/>
+                        </a:rPr>
+                        <a:t>自愈策略</a:t>
+                      </a:r>
+                    </a:p>
+                  </a:txBody>
+                  <a:tcPr>
+                    <a:solidFill>
+                      <a:srgbClr val="2563EB"/>
+                    </a:solidFill>
+                  </a:tcPr>
+                </a:tc>
+                <a:tc>
+                  <a:txBody>
+                    <a:bodyPr wrap="square"/>
+                    <a:lstStyle/>
+                    <a:p>
+                      <a:pPr algn="ctr"/>
+                      <a:r>
+                        <a:rPr sz="1300" b="1">
+                          <a:solidFill>
+                            <a:srgbClr val="FFFFFF"/>
+                          </a:solidFill>
+                          <a:latin typeface="PingFang SC, Inter, sans-serif"/>
+                        </a:rPr>
+                        <a:t>合规评级</a:t>
+                      </a:r>
+                    </a:p>
+                  </a:txBody>
+                  <a:tcPr>
+                    <a:solidFill>
+                      <a:srgbClr val="2563EB"/>
+                    </a:solidFill>
+                  </a:tcPr>
+                </a:tc>
+              </a:tr>
+              <a:tr h="548640">
+                <a:tc>
+                  <a:txBody>
+                    <a:bodyPr wrap="square"/>
+                    <a:lstStyle/>
+                    <a:p>
+                      <a:pPr algn="l"/>
+                      <a:r>
+                        <a:rPr sz="1100">
+                          <a:solidFill>
+                            <a:srgbClr val="0F172A"/>
+                          </a:solidFill>
+                          <a:latin typeface="PingFang SC, Inter, sans-serif"/>
+                        </a:rPr>
+                        <a:t>意图研判探针</a:t>
+                      </a:r>
+                    </a:p>
+                  </a:txBody>
+                  <a:tcPr>
+                    <a:solidFill>
+                      <a:srgbClr val="F1F5F9"/>
+                    </a:solidFill>
+                  </a:tcPr>
+                </a:tc>
+                <a:tc>
+                  <a:txBody>
+                    <a:bodyPr wrap="square"/>
+                    <a:lstStyle/>
+                    <a:p>
+                      <a:pPr algn="ctr"/>
+                      <a:r>
+                        <a:rPr sz="1100">
+                          <a:solidFill>
+                            <a:srgbClr val="0F172A"/>
+                          </a:solidFill>
+                          <a:latin typeface="PingFang SC, Inter, sans-serif"/>
+                        </a:rPr>
+                        <a:t>上下文语义解析与盲区嗅探</a:t>
+                      </a:r>
+                    </a:p>
+                  </a:txBody>
+                  <a:tcPr>
+                    <a:solidFill>
+                      <a:srgbClr val="F1F5F9"/>
+                    </a:solidFill>
+                  </a:tcPr>
+                </a:tc>
+                <a:tc>
+                  <a:txBody>
+                    <a:bodyPr wrap="square"/>
+                    <a:lstStyle/>
+                    <a:p>
+                      <a:pPr algn="ctr"/>
+                      <a:r>
+                        <a:rPr sz="1100">
+                          <a:solidFill>
+                            <a:srgbClr val="0F172A"/>
+                          </a:solidFill>
+                          <a:latin typeface="PingFang SC, Inter, sans-serif"/>
+                        </a:rPr>
+                        <a:t>&lt;50ms</a:t>
+                      </a:r>
+                    </a:p>
+                  </a:txBody>
+                  <a:tcPr>
+                    <a:solidFill>
+                      <a:srgbClr val="F1F5F9"/>
+                    </a:solidFill>
+                  </a:tcPr>
+                </a:tc>
+                <a:tc>
+                  <a:txBody>
+                    <a:bodyPr wrap="square"/>
+                    <a:lstStyle/>
+                    <a:p>
+                      <a:pPr algn="ctr"/>
+                      <a:r>
+                        <a:rPr sz="1100">
+                          <a:solidFill>
+                            <a:srgbClr val="0F172A"/>
+                          </a:solidFill>
+                          <a:latin typeface="PingFang SC, Inter, sans-serif"/>
+                        </a:rPr>
+                        <a:t>自适应多轮澄清</a:t>
+                      </a:r>
+                    </a:p>
+                  </a:txBody>
+                  <a:tcPr>
+                    <a:solidFill>
+                      <a:srgbClr val="F1F5F9"/>
+                    </a:solidFill>
+                  </a:tcPr>
+                </a:tc>
+                <a:tc>
+                  <a:txBody>
+                    <a:bodyPr wrap="square"/>
+                    <a:lstStyle/>
+                    <a:p>
+                      <a:pPr algn="ctr"/>
+                      <a:r>
+                        <a:rPr sz="1100">
+                          <a:solidFill>
+                            <a:srgbClr val="0F172A"/>
+                          </a:solidFill>
+                          <a:latin typeface="PingFang SC, Inter, sans-serif"/>
+                        </a:rPr>
+                        <a:t>L4 级安全</a:t>
+                      </a:r>
+                    </a:p>
+                  </a:txBody>
+                  <a:tcPr>
+                    <a:solidFill>
+                      <a:srgbClr val="F1F5F9"/>
+                    </a:solidFill>
+                  </a:tcPr>
+                </a:tc>
+              </a:tr>
+              <a:tr h="548640">
+                <a:tc>
+                  <a:txBody>
+                    <a:bodyPr wrap="square"/>
+                    <a:lstStyle/>
+                    <a:p>
+                      <a:pPr algn="l"/>
+                      <a:r>
+                        <a:rPr sz="1100">
+                          <a:solidFill>
+                            <a:srgbClr val="0F172A"/>
+                          </a:solidFill>
+                          <a:latin typeface="PingFang SC, Inter, sans-serif"/>
+                        </a:rPr>
+                        <a:t>解构分析引擎</a:t>
+                      </a:r>
+                    </a:p>
+                  </a:txBody>
+                  <a:tcPr>
+                    <a:solidFill>
+                      <a:srgbClr val="FFFFFF"/>
+                    </a:solidFill>
+                  </a:tcPr>
+                </a:tc>
+                <a:tc>
+                  <a:txBody>
+                    <a:bodyPr wrap="square"/>
+                    <a:lstStyle/>
+                    <a:p>
+                      <a:pPr algn="ctr"/>
+                      <a:r>
+                        <a:rPr sz="1100">
+                          <a:solidFill>
+                            <a:srgbClr val="0F172A"/>
+                          </a:solidFill>
+                          <a:latin typeface="PingFang SC, Inter, sans-serif"/>
+                        </a:rPr>
+                        <a:t>多版式 AST 逆向与母版穿透</a:t>
+                      </a:r>
+                    </a:p>
+                  </a:txBody>
+                  <a:tcPr>
+                    <a:solidFill>
+                      <a:srgbClr val="FFFFFF"/>
+                    </a:solidFill>
+                  </a:tcPr>
+                </a:tc>
+                <a:tc>
+                  <a:txBody>
+                    <a:bodyPr wrap="square"/>
+                    <a:lstStyle/>
+                    <a:p>
+                      <a:pPr algn="ctr"/>
+                      <a:r>
+                        <a:rPr sz="1100">
+                          <a:solidFill>
+                            <a:srgbClr val="0F172A"/>
+                          </a:solidFill>
+                          <a:latin typeface="PingFang SC, Inter, sans-serif"/>
+                        </a:rPr>
+                        <a:t>&lt;120ms</a:t>
+                      </a:r>
+                    </a:p>
+                  </a:txBody>
+                  <a:tcPr>
+                    <a:solidFill>
+                      <a:srgbClr val="FFFFFF"/>
+                    </a:solidFill>
+                  </a:tcPr>
+                </a:tc>
+                <a:tc>
+                  <a:txBody>
+                    <a:bodyPr wrap="square"/>
+                    <a:lstStyle/>
+                    <a:p>
+                      <a:pPr algn="ctr"/>
+                      <a:r>
+                        <a:rPr sz="1100">
+                          <a:solidFill>
+                            <a:srgbClr val="0F172A"/>
+                          </a:solidFill>
+                          <a:latin typeface="PingFang SC, Inter, sans-serif"/>
+                        </a:rPr>
+                        <a:t>启发式降级映射</a:t>
+                      </a:r>
+                    </a:p>
+                  </a:txBody>
+                  <a:tcPr>
+                    <a:solidFill>
+                      <a:srgbClr val="FFFFFF"/>
+                    </a:solidFill>
+                  </a:tcPr>
+                </a:tc>
+                <a:tc>
+                  <a:txBody>
+                    <a:bodyPr wrap="square"/>
+                    <a:lstStyle/>
+                    <a:p>
+                      <a:pPr algn="ctr"/>
+                      <a:r>
+                        <a:rPr sz="1100">
+                          <a:solidFill>
+                            <a:srgbClr val="0F172A"/>
+                          </a:solidFill>
+                          <a:latin typeface="PingFang SC, Inter, sans-serif"/>
+                        </a:rPr>
+                        <a:t>原生矢量认证</a:t>
+                      </a:r>
+                    </a:p>
+                  </a:txBody>
+                  <a:tcPr>
+                    <a:solidFill>
+                      <a:srgbClr val="FFFFFF"/>
+                    </a:solidFill>
+                  </a:tcPr>
+                </a:tc>
+              </a:tr>
+              <a:tr h="548640">
+                <a:tc>
+                  <a:txBody>
+                    <a:bodyPr wrap="square"/>
+                    <a:lstStyle/>
+                    <a:p>
+                      <a:pPr algn="l"/>
+                      <a:r>
+                        <a:rPr sz="1100">
+                          <a:solidFill>
+                            <a:srgbClr val="0F172A"/>
+                          </a:solidFill>
+                          <a:latin typeface="PingFang SC, Inter, sans-serif"/>
+                        </a:rPr>
+                        <a:t>协同感知哨兵</a:t>
+                      </a:r>
+                    </a:p>
+                  </a:txBody>
+                  <a:tcPr>
+                    <a:solidFill>
+                      <a:srgbClr val="F1F5F9"/>
+                    </a:solidFill>
+                  </a:tcPr>
+                </a:tc>
+                <a:tc>
+                  <a:txBody>
+                    <a:bodyPr wrap="square"/>
+                    <a:lstStyle/>
+                    <a:p>
+                      <a:pPr algn="ctr"/>
+                      <a:r>
+                        <a:rPr sz="1100">
+                          <a:solidFill>
+                            <a:srgbClr val="0F172A"/>
+                          </a:solidFill>
+                          <a:latin typeface="PingFang SC, Inter, sans-serif"/>
+                        </a:rPr>
+                        <a:t>文件指纹与非侵入增量感知</a:t>
+                      </a:r>
+                    </a:p>
+                  </a:txBody>
+                  <a:tcPr>
+                    <a:solidFill>
+                      <a:srgbClr val="F1F5F9"/>
+                    </a:solidFill>
+                  </a:tcPr>
+                </a:tc>
+                <a:tc>
+                  <a:txBody>
+                    <a:bodyPr wrap="square"/>
+                    <a:lstStyle/>
+                    <a:p>
+                      <a:pPr algn="ctr"/>
+                      <a:r>
+                        <a:rPr sz="1100">
+                          <a:solidFill>
+                            <a:srgbClr val="0F172A"/>
+                          </a:solidFill>
+                          <a:latin typeface="PingFang SC, Inter, sans-serif"/>
+                        </a:rPr>
+                        <a:t>&lt;8ms</a:t>
+                      </a:r>
+                    </a:p>
+                  </a:txBody>
+                  <a:tcPr>
+                    <a:solidFill>
+                      <a:srgbClr val="F1F5F9"/>
+                    </a:solidFill>
+                  </a:tcPr>
+                </a:tc>
+                <a:tc>
+                  <a:txBody>
+                    <a:bodyPr wrap="square"/>
+                    <a:lstStyle/>
+                    <a:p>
+                      <a:pPr algn="ctr"/>
+                      <a:r>
+                        <a:rPr sz="1100">
+                          <a:solidFill>
+                            <a:srgbClr val="0F172A"/>
+                          </a:solidFill>
+                          <a:latin typeface="PingFang SC, Inter, sans-serif"/>
+                        </a:rPr>
+                        <a:t>状态快照自动回滚</a:t>
+                      </a:r>
+                    </a:p>
+                  </a:txBody>
+                  <a:tcPr>
+                    <a:solidFill>
+                      <a:srgbClr val="F1F5F9"/>
+                    </a:solidFill>
+                  </a:tcPr>
+                </a:tc>
+                <a:tc>
+                  <a:txBody>
+                    <a:bodyPr wrap="square"/>
+                    <a:lstStyle/>
+                    <a:p>
+                      <a:pPr algn="ctr"/>
+                      <a:r>
+                        <a:rPr sz="1100">
+                          <a:solidFill>
+                            <a:srgbClr val="0F172A"/>
+                          </a:solidFill>
+                          <a:latin typeface="PingFang SC, Inter, sans-serif"/>
+                        </a:rPr>
+                        <a:t>100% 审计追踪</a:t>
+                      </a:r>
+                    </a:p>
+                  </a:txBody>
+                  <a:tcPr>
+                    <a:solidFill>
+                      <a:srgbClr val="F1F5F9"/>
+                    </a:solidFill>
+                  </a:tcPr>
+                </a:tc>
+              </a:tr>
+              <a:tr h="548640">
+                <a:tc>
+                  <a:txBody>
+                    <a:bodyPr wrap="square"/>
+                    <a:lstStyle/>
+                    <a:p>
+                      <a:pPr algn="l"/>
+                      <a:r>
+                        <a:rPr sz="1100">
+                          <a:solidFill>
+                            <a:srgbClr val="0F172A"/>
+                          </a:solidFill>
+                          <a:latin typeface="PingFang SC, Inter, sans-serif"/>
+                        </a:rPr>
+                        <a:t>工具沙箱集群</a:t>
+                      </a:r>
+                    </a:p>
+                  </a:txBody>
+                  <a:tcPr>
+                    <a:solidFill>
+                      <a:srgbClr val="FFFFFF"/>
+                    </a:solidFill>
+                  </a:tcPr>
+                </a:tc>
+                <a:tc>
+                  <a:txBody>
+                    <a:bodyPr wrap="square"/>
+                    <a:lstStyle/>
+                    <a:p>
+                      <a:pPr algn="ctr"/>
+                      <a:r>
+                        <a:rPr sz="1100">
+                          <a:solidFill>
+                            <a:srgbClr val="0F172A"/>
+                          </a:solidFill>
+                          <a:latin typeface="PingFang SC, Inter, sans-serif"/>
+                        </a:rPr>
+                        <a:t>容器化隔离代码与 MCP 执行</a:t>
+                      </a:r>
+                    </a:p>
+                  </a:txBody>
+                  <a:tcPr>
+                    <a:solidFill>
+                      <a:srgbClr val="FFFFFF"/>
+                    </a:solidFill>
+                  </a:tcPr>
+                </a:tc>
+                <a:tc>
+                  <a:txBody>
+                    <a:bodyPr wrap="square"/>
+                    <a:lstStyle/>
+                    <a:p>
+                      <a:pPr algn="ctr"/>
+                      <a:r>
+                        <a:rPr sz="1100">
+                          <a:solidFill>
+                            <a:srgbClr val="0F172A"/>
+                          </a:solidFill>
+                          <a:latin typeface="PingFang SC, Inter, sans-serif"/>
+                        </a:rPr>
+                        <a:t>&lt;200ms</a:t>
+                      </a:r>
+                    </a:p>
+                  </a:txBody>
+                  <a:tcPr>
+                    <a:solidFill>
+                      <a:srgbClr val="FFFFFF"/>
+                    </a:solidFill>
+                  </a:tcPr>
+                </a:tc>
+                <a:tc>
+                  <a:txBody>
+                    <a:bodyPr wrap="square"/>
+                    <a:lstStyle/>
+                    <a:p>
+                      <a:pPr algn="ctr"/>
+                      <a:r>
+                        <a:rPr sz="1100">
+                          <a:solidFill>
+                            <a:srgbClr val="0F172A"/>
+                          </a:solidFill>
+                          <a:latin typeface="PingFang SC, Inter, sans-serif"/>
+                        </a:rPr>
+                        <a:t>超时阻断与隔离恢复</a:t>
+                      </a:r>
+                    </a:p>
+                  </a:txBody>
+                  <a:tcPr>
+                    <a:solidFill>
+                      <a:srgbClr val="FFFFFF"/>
+                    </a:solidFill>
+                  </a:tcPr>
+                </a:tc>
+                <a:tc>
+                  <a:txBody>
+                    <a:bodyPr wrap="square"/>
+                    <a:lstStyle/>
+                    <a:p>
+                      <a:pPr algn="ctr"/>
+                      <a:r>
+                        <a:rPr sz="1100">
+                          <a:solidFill>
+                            <a:srgbClr val="0F172A"/>
+                          </a:solidFill>
+                          <a:latin typeface="PingFang SC, Inter, sans-serif"/>
+                        </a:rPr>
+                        <a:t>金融级沙箱</a:t>
+                      </a:r>
+                    </a:p>
+                  </a:txBody>
+                  <a:tcPr>
+                    <a:solidFill>
+                      <a:srgbClr val="FFFFFF"/>
+                    </a:solidFill>
+                  </a:tcPr>
+                </a:tc>
+              </a:tr>
+            </a:tbl>
+          </a:graphicData>
+        </a:graphic>
+      </p:graphicFrame>
+    </p:spTree>
+  </p:cSld>
+  <p:clrMapOvr>
+    <a:masterClrMapping/>
+  </p:clrMapOvr>
+</p:sld>
+</file>
+
+<file path=ppt/slides/slide7.xml><?xml version="1.0" encoding="utf-8"?>
+<p:sld xmlns:a="http://schemas.openxmlformats.org/drawingml/2006/main" xmlns:p="http://schemas.openxmlformats.org/presentationml/2006/main" xmlns:r="http://schemas.openxmlformats.org/officeDocument/2006/relationships">
+  <p:cSld>
+    <p:spTree>
+      <p:nvGrpSpPr>
+        <p:cNvPr id="1" name=""/>
+        <p:cNvGrpSpPr/>
+        <p:nvPr/>
+      </p:nvGrpSpPr>
+      <p:grpSpPr/>
+      <p:sp>
+        <p:nvSpPr>
+          <p:cNvPr id="2" name="Rectangle 1"/>
+          <p:cNvSpPr/>
+          <p:nvPr/>
+        </p:nvSpPr>
+        <p:spPr>
+          <a:xfrm>
+            <a:off x="0" y="0"/>
+            <a:ext cx="12191695" cy="6858000"/>
+          </a:xfrm>
+          <a:prstGeom prst="rect">
+            <a:avLst/>
+          </a:prstGeom>
+          <a:solidFill>
+            <a:srgbClr val="F8FAFC"/>
+          </a:solidFill>
+          <a:ln>
+            <a:noFill/>
+          </a:ln>
+        </p:spPr>
+        <p:style>
+          <a:lnRef idx="1">
+            <a:schemeClr val="accent1"/>
+          </a:lnRef>
+          <a:fillRef idx="3">
+            <a:schemeClr val="accent1"/>
+          </a:fillRef>
+          <a:effectRef idx="2">
+            <a:schemeClr val="accent1"/>
+          </a:effectRef>
+          <a:fontRef idx="minor">
+            <a:schemeClr val="lt1"/>
+          </a:fontRef>
+        </p:style>
+        <p:txBody>
+          <a:bodyPr rtlCol="0" anchor="ctr"/>
+          <a:lstStyle/>
+          <a:p>
+            <a:pPr algn="ctr"/>
+          </a:p>
+        </p:txBody>
+      </p:sp>
+      <p:sp>
+        <p:nvSpPr>
+          <p:cNvPr id="3" name="Rounded Rectangle 2"/>
+          <p:cNvSpPr/>
+          <p:nvPr/>
+        </p:nvSpPr>
+        <p:spPr>
+          <a:xfrm>
+            <a:off x="731520" y="685800"/>
+            <a:ext cx="1645920" cy="292608"/>
+          </a:xfrm>
+          <a:prstGeom prst="roundRect">
+            <a:avLst/>
+          </a:prstGeom>
+          <a:solidFill>
+            <a:srgbClr val="F1F5F9"/>
+          </a:solidFill>
+          <a:ln w="12700">
+            <a:solidFill>
+              <a:srgbClr val="38BDF8"/>
+            </a:solidFill>
+          </a:ln>
+        </p:spPr>
+        <p:style>
+          <a:lnRef idx="1">
+            <a:schemeClr val="accent1"/>
+          </a:lnRef>
+          <a:fillRef idx="3">
+            <a:schemeClr val="accent1"/>
+          </a:fillRef>
+          <a:effectRef idx="2">
+            <a:schemeClr val="accent1"/>
+          </a:effectRef>
+          <a:fontRef idx="minor">
+            <a:schemeClr val="lt1"/>
+          </a:fontRef>
+        </p:style>
+        <p:txBody>
+          <a:bodyPr rtlCol="0" anchor="ctr" wrap="square"/>
+          <a:lstStyle/>
+          <a:p>
+            <a:pPr algn="ctr"/>
+            <a:r>
+              <a:rPr sz="1000" b="1">
+                <a:solidFill>
+                  <a:srgbClr val="2563EB"/>
+                </a:solidFill>
+                <a:latin typeface="PingFang SC, Inter, sans-serif"/>
+              </a:rPr>
               <a:t>PROGRESSION</a:t>
             </a:r>
           </a:p>
@@ -7781,7 +9230,7 @@
 </p:sld>
 </file>
 
-<file path=ppt/slides/slide6.xml><?xml version="1.0" encoding="utf-8"?>
+<file path=ppt/slides/slide8.xml><?xml version="1.0" encoding="utf-8"?>
 <p:sld xmlns:a="http://schemas.openxmlformats.org/drawingml/2006/main" xmlns:p="http://schemas.openxmlformats.org/presentationml/2006/main" xmlns:r="http://schemas.openxmlformats.org/officeDocument/2006/relationships">
   <p:cSld>
     <p:spTree>

</xml_diff>

<commit_message>
feat: release v3.3.0 with kinetic dynamics and interactive decision sandbox
</commit_message>
<xml_diff>
--- a/output/presentation.pptx
+++ b/output/presentation.pptx
@@ -5311,6 +5311,289 @@
   <p:transition spd="fast" advClick="1">
     <p:fade/>
   </p:transition>
+  <p:timing>
+    <p:tnLst>
+      <p:par>
+        <p:cTn id="1" dur="indefinite" restart="always" nodeType="tmRoot">
+          <p:childTnLst>
+            <p:seq concurrent="1" nextAc="seek">
+              <p:cTn id="2" dur="indefinite" nodeType="mainSeq">
+                <p:childTnLst>
+                  <p:par>
+                    <p:cTn id="3" fill="hold">
+                      <p:stCondLst>
+                        <p:cond delay="0"/>
+                      </p:stCondLst>
+                      <p:childTnLst>
+                        <p:par>
+                          <p:cTn id="4" fill="hold">
+                            <p:stCondLst>
+                              <p:cond delay="0"/>
+                            </p:stCondLst>
+                            <p:childTnLst>
+                              <p:set>
+                                <p:cBhvr>
+                                  <p:cTn id="5" dur="1" fill="hold">
+                                    <p:stCondLst>
+                                      <p:cond delay="0"/>
+                                    </p:stCondLst>
+                                  </p:cTn>
+                                  <p:tgtEl>
+                                    <p:spTgt spid="5"/>
+                                  </p:tgtEl>
+                                  <p:attrNameLst>
+                                    <p:attrName>style.visibility</p:attrName>
+                                  </p:attrNameLst>
+                                </p:cBhvr>
+                                <p:to>
+                                  <p:strVal val="visible"/>
+                                </p:to>
+                              </p:set>
+                              <p:animEffect transition="in" filter="fade">
+                                <p:cBhvr>
+                                  <p:cTn id="6" dur="250">
+                                    <p:stCondLst>
+                                      <p:cond delay="0"/>
+                                    </p:stCondLst>
+                                  </p:cTn>
+                                  <p:tgtEl>
+                                    <p:spTgt spid="5"/>
+                                  </p:tgtEl>
+                                </p:cBhvr>
+                              </p:animEffect>
+                            </p:childTnLst>
+                          </p:cTn>
+                        </p:par>
+                        <p:par>
+                          <p:cTn id="7" fill="hold">
+                            <p:stCondLst>
+                              <p:cond delay="0"/>
+                            </p:stCondLst>
+                            <p:childTnLst>
+                              <p:set>
+                                <p:cBhvr>
+                                  <p:cTn id="8" dur="1" fill="hold">
+                                    <p:stCondLst>
+                                      <p:cond delay="0"/>
+                                    </p:stCondLst>
+                                  </p:cTn>
+                                  <p:tgtEl>
+                                    <p:spTgt spid="6"/>
+                                  </p:tgtEl>
+                                  <p:attrNameLst>
+                                    <p:attrName>style.visibility</p:attrName>
+                                  </p:attrNameLst>
+                                </p:cBhvr>
+                                <p:to>
+                                  <p:strVal val="visible"/>
+                                </p:to>
+                              </p:set>
+                              <p:animEffect transition="in" filter="fade">
+                                <p:cBhvr>
+                                  <p:cTn id="9" dur="250">
+                                    <p:stCondLst>
+                                      <p:cond delay="0"/>
+                                    </p:stCondLst>
+                                  </p:cTn>
+                                  <p:tgtEl>
+                                    <p:spTgt spid="6"/>
+                                  </p:tgtEl>
+                                </p:cBhvr>
+                              </p:animEffect>
+                            </p:childTnLst>
+                          </p:cTn>
+                        </p:par>
+                      </p:childTnLst>
+                    </p:cTn>
+                  </p:par>
+                  <p:par>
+                    <p:cTn id="10" fill="hold">
+                      <p:stCondLst>
+                        <p:cond delay="0"/>
+                      </p:stCondLst>
+                      <p:childTnLst>
+                        <p:par>
+                          <p:cTn id="11" fill="hold">
+                            <p:stCondLst>
+                              <p:cond delay="0"/>
+                            </p:stCondLst>
+                            <p:childTnLst>
+                              <p:set>
+                                <p:cBhvr>
+                                  <p:cTn id="12" dur="1" fill="hold">
+                                    <p:stCondLst>
+                                      <p:cond delay="0"/>
+                                    </p:stCondLst>
+                                  </p:cTn>
+                                  <p:tgtEl>
+                                    <p:spTgt spid="7"/>
+                                  </p:tgtEl>
+                                  <p:attrNameLst>
+                                    <p:attrName>style.visibility</p:attrName>
+                                  </p:attrNameLst>
+                                </p:cBhvr>
+                                <p:to>
+                                  <p:strVal val="visible"/>
+                                </p:to>
+                              </p:set>
+                              <p:animEffect transition="in" filter="fade">
+                                <p:cBhvr>
+                                  <p:cTn id="13" dur="250">
+                                    <p:stCondLst>
+                                      <p:cond delay="0"/>
+                                    </p:stCondLst>
+                                  </p:cTn>
+                                  <p:tgtEl>
+                                    <p:spTgt spid="7"/>
+                                  </p:tgtEl>
+                                </p:cBhvr>
+                              </p:animEffect>
+                            </p:childTnLst>
+                          </p:cTn>
+                        </p:par>
+                        <p:par>
+                          <p:cTn id="14" fill="hold">
+                            <p:stCondLst>
+                              <p:cond delay="0"/>
+                            </p:stCondLst>
+                            <p:childTnLst>
+                              <p:set>
+                                <p:cBhvr>
+                                  <p:cTn id="15" dur="1" fill="hold">
+                                    <p:stCondLst>
+                                      <p:cond delay="0"/>
+                                    </p:stCondLst>
+                                  </p:cTn>
+                                  <p:tgtEl>
+                                    <p:spTgt spid="8"/>
+                                  </p:tgtEl>
+                                  <p:attrNameLst>
+                                    <p:attrName>style.visibility</p:attrName>
+                                  </p:attrNameLst>
+                                </p:cBhvr>
+                                <p:to>
+                                  <p:strVal val="visible"/>
+                                </p:to>
+                              </p:set>
+                              <p:animEffect transition="in" filter="fade">
+                                <p:cBhvr>
+                                  <p:cTn id="16" dur="250">
+                                    <p:stCondLst>
+                                      <p:cond delay="0"/>
+                                    </p:stCondLst>
+                                  </p:cTn>
+                                  <p:tgtEl>
+                                    <p:spTgt spid="8"/>
+                                  </p:tgtEl>
+                                </p:cBhvr>
+                              </p:animEffect>
+                            </p:childTnLst>
+                          </p:cTn>
+                        </p:par>
+                      </p:childTnLst>
+                    </p:cTn>
+                  </p:par>
+                  <p:par>
+                    <p:cTn id="17" fill="hold">
+                      <p:stCondLst>
+                        <p:cond delay="0"/>
+                      </p:stCondLst>
+                      <p:childTnLst>
+                        <p:par>
+                          <p:cTn id="18" fill="hold">
+                            <p:stCondLst>
+                              <p:cond delay="0"/>
+                            </p:stCondLst>
+                            <p:childTnLst>
+                              <p:set>
+                                <p:cBhvr>
+                                  <p:cTn id="19" dur="1" fill="hold">
+                                    <p:stCondLst>
+                                      <p:cond delay="0"/>
+                                    </p:stCondLst>
+                                  </p:cTn>
+                                  <p:tgtEl>
+                                    <p:spTgt spid="9"/>
+                                  </p:tgtEl>
+                                  <p:attrNameLst>
+                                    <p:attrName>style.visibility</p:attrName>
+                                  </p:attrNameLst>
+                                </p:cBhvr>
+                                <p:to>
+                                  <p:strVal val="visible"/>
+                                </p:to>
+                              </p:set>
+                              <p:animEffect transition="in" filter="fade">
+                                <p:cBhvr>
+                                  <p:cTn id="20" dur="250">
+                                    <p:stCondLst>
+                                      <p:cond delay="0"/>
+                                    </p:stCondLst>
+                                  </p:cTn>
+                                  <p:tgtEl>
+                                    <p:spTgt spid="9"/>
+                                  </p:tgtEl>
+                                </p:cBhvr>
+                              </p:animEffect>
+                            </p:childTnLst>
+                          </p:cTn>
+                        </p:par>
+                        <p:par>
+                          <p:cTn id="21" fill="hold">
+                            <p:stCondLst>
+                              <p:cond delay="0"/>
+                            </p:stCondLst>
+                            <p:childTnLst>
+                              <p:set>
+                                <p:cBhvr>
+                                  <p:cTn id="22" dur="1" fill="hold">
+                                    <p:stCondLst>
+                                      <p:cond delay="0"/>
+                                    </p:stCondLst>
+                                  </p:cTn>
+                                  <p:tgtEl>
+                                    <p:spTgt spid="10"/>
+                                  </p:tgtEl>
+                                  <p:attrNameLst>
+                                    <p:attrName>style.visibility</p:attrName>
+                                  </p:attrNameLst>
+                                </p:cBhvr>
+                                <p:to>
+                                  <p:strVal val="visible"/>
+                                </p:to>
+                              </p:set>
+                              <p:animEffect transition="in" filter="fade">
+                                <p:cBhvr>
+                                  <p:cTn id="23" dur="250">
+                                    <p:stCondLst>
+                                      <p:cond delay="0"/>
+                                    </p:stCondLst>
+                                  </p:cTn>
+                                  <p:tgtEl>
+                                    <p:spTgt spid="10"/>
+                                  </p:tgtEl>
+                                </p:cBhvr>
+                              </p:animEffect>
+                            </p:childTnLst>
+                          </p:cTn>
+                        </p:par>
+                      </p:childTnLst>
+                    </p:cTn>
+                  </p:par>
+                </p:childTnLst>
+              </p:cTn>
+              <p:prevCondLst>
+                <p:cond evt="onPrev" delay="0"/>
+              </p:prevCondLst>
+              <p:nextCondLst>
+                <p:cond evt="onNext" delay="0"/>
+              </p:nextCondLst>
+            </p:seq>
+          </p:childTnLst>
+        </p:cTn>
+      </p:par>
+    </p:tnLst>
+  </p:timing>
 </p:sld>
 </file>
 
@@ -6442,6 +6725,757 @@
   <p:transition spd="fast" advClick="1">
     <p:fade/>
   </p:transition>
+  <p:timing>
+    <p:tnLst>
+      <p:par>
+        <p:cTn id="1" dur="indefinite" restart="always" nodeType="tmRoot">
+          <p:childTnLst>
+            <p:seq concurrent="1" nextAc="seek">
+              <p:cTn id="2" dur="indefinite" nodeType="mainSeq">
+                <p:childTnLst>
+                  <p:par>
+                    <p:cTn id="3" fill="hold">
+                      <p:stCondLst>
+                        <p:cond delay="0"/>
+                      </p:stCondLst>
+                      <p:childTnLst>
+                        <p:par>
+                          <p:cTn id="4" fill="hold">
+                            <p:stCondLst>
+                              <p:cond delay="0"/>
+                            </p:stCondLst>
+                            <p:childTnLst>
+                              <p:set>
+                                <p:cBhvr>
+                                  <p:cTn id="5" dur="1" fill="hold">
+                                    <p:stCondLst>
+                                      <p:cond delay="0"/>
+                                    </p:stCondLst>
+                                  </p:cTn>
+                                  <p:tgtEl>
+                                    <p:spTgt spid="19"/>
+                                  </p:tgtEl>
+                                  <p:attrNameLst>
+                                    <p:attrName>style.visibility</p:attrName>
+                                  </p:attrNameLst>
+                                </p:cBhvr>
+                                <p:to>
+                                  <p:strVal val="visible"/>
+                                </p:to>
+                              </p:set>
+                              <p:animEffect transition="in" filter="fade">
+                                <p:cBhvr>
+                                  <p:cTn id="6" dur="400">
+                                    <p:stCondLst>
+                                      <p:cond delay="0"/>
+                                    </p:stCondLst>
+                                  </p:cTn>
+                                  <p:tgtEl>
+                                    <p:spTgt spid="19"/>
+                                  </p:tgtEl>
+                                </p:cBhvr>
+                              </p:animEffect>
+                            </p:childTnLst>
+                          </p:cTn>
+                        </p:par>
+                        <p:par>
+                          <p:cTn id="7" fill="hold">
+                            <p:stCondLst>
+                              <p:cond delay="0"/>
+                            </p:stCondLst>
+                            <p:childTnLst>
+                              <p:set>
+                                <p:cBhvr>
+                                  <p:cTn id="8" dur="1" fill="hold">
+                                    <p:stCondLst>
+                                      <p:cond delay="0"/>
+                                    </p:stCondLst>
+                                  </p:cTn>
+                                  <p:tgtEl>
+                                    <p:spTgt spid="20"/>
+                                  </p:tgtEl>
+                                  <p:attrNameLst>
+                                    <p:attrName>style.visibility</p:attrName>
+                                  </p:attrNameLst>
+                                </p:cBhvr>
+                                <p:to>
+                                  <p:strVal val="visible"/>
+                                </p:to>
+                              </p:set>
+                              <p:animEffect transition="in" filter="fade">
+                                <p:cBhvr>
+                                  <p:cTn id="9" dur="400">
+                                    <p:stCondLst>
+                                      <p:cond delay="0"/>
+                                    </p:stCondLst>
+                                  </p:cTn>
+                                  <p:tgtEl>
+                                    <p:spTgt spid="20"/>
+                                  </p:tgtEl>
+                                </p:cBhvr>
+                              </p:animEffect>
+                            </p:childTnLst>
+                          </p:cTn>
+                        </p:par>
+                        <p:par>
+                          <p:cTn id="10" fill="hold">
+                            <p:stCondLst>
+                              <p:cond delay="0"/>
+                            </p:stCondLst>
+                            <p:childTnLst>
+                              <p:set>
+                                <p:cBhvr>
+                                  <p:cTn id="11" dur="1" fill="hold">
+                                    <p:stCondLst>
+                                      <p:cond delay="0"/>
+                                    </p:stCondLst>
+                                  </p:cTn>
+                                  <p:tgtEl>
+                                    <p:spTgt spid="21"/>
+                                  </p:tgtEl>
+                                  <p:attrNameLst>
+                                    <p:attrName>style.visibility</p:attrName>
+                                  </p:attrNameLst>
+                                </p:cBhvr>
+                                <p:to>
+                                  <p:strVal val="visible"/>
+                                </p:to>
+                              </p:set>
+                              <p:animEffect transition="in" filter="fade">
+                                <p:cBhvr>
+                                  <p:cTn id="12" dur="400">
+                                    <p:stCondLst>
+                                      <p:cond delay="0"/>
+                                    </p:stCondLst>
+                                  </p:cTn>
+                                  <p:tgtEl>
+                                    <p:spTgt spid="21"/>
+                                  </p:tgtEl>
+                                </p:cBhvr>
+                              </p:animEffect>
+                            </p:childTnLst>
+                          </p:cTn>
+                        </p:par>
+                        <p:par>
+                          <p:cTn id="13" fill="hold">
+                            <p:stCondLst>
+                              <p:cond delay="0"/>
+                            </p:stCondLst>
+                            <p:childTnLst>
+                              <p:set>
+                                <p:cBhvr>
+                                  <p:cTn id="14" dur="1" fill="hold">
+                                    <p:stCondLst>
+                                      <p:cond delay="0"/>
+                                    </p:stCondLst>
+                                  </p:cTn>
+                                  <p:tgtEl>
+                                    <p:spTgt spid="22"/>
+                                  </p:tgtEl>
+                                  <p:attrNameLst>
+                                    <p:attrName>style.visibility</p:attrName>
+                                  </p:attrNameLst>
+                                </p:cBhvr>
+                                <p:to>
+                                  <p:strVal val="visible"/>
+                                </p:to>
+                              </p:set>
+                              <p:animEffect transition="in" filter="fade">
+                                <p:cBhvr>
+                                  <p:cTn id="15" dur="400">
+                                    <p:stCondLst>
+                                      <p:cond delay="0"/>
+                                    </p:stCondLst>
+                                  </p:cTn>
+                                  <p:tgtEl>
+                                    <p:spTgt spid="22"/>
+                                  </p:tgtEl>
+                                </p:cBhvr>
+                              </p:animEffect>
+                            </p:childTnLst>
+                          </p:cTn>
+                        </p:par>
+                        <p:par>
+                          <p:cTn id="16" fill="hold">
+                            <p:stCondLst>
+                              <p:cond delay="0"/>
+                            </p:stCondLst>
+                            <p:childTnLst>
+                              <p:set>
+                                <p:cBhvr>
+                                  <p:cTn id="17" dur="1" fill="hold">
+                                    <p:stCondLst>
+                                      <p:cond delay="0"/>
+                                    </p:stCondLst>
+                                  </p:cTn>
+                                  <p:tgtEl>
+                                    <p:spTgt spid="18"/>
+                                  </p:tgtEl>
+                                  <p:attrNameLst>
+                                    <p:attrName>style.visibility</p:attrName>
+                                  </p:attrNameLst>
+                                </p:cBhvr>
+                                <p:to>
+                                  <p:strVal val="visible"/>
+                                </p:to>
+                              </p:set>
+                              <p:animEffect transition="in" filter="fade">
+                                <p:cBhvr>
+                                  <p:cTn id="18" dur="400">
+                                    <p:stCondLst>
+                                      <p:cond delay="0"/>
+                                    </p:stCondLst>
+                                  </p:cTn>
+                                  <p:tgtEl>
+                                    <p:spTgt spid="18"/>
+                                  </p:tgtEl>
+                                </p:cBhvr>
+                              </p:animEffect>
+                            </p:childTnLst>
+                          </p:cTn>
+                        </p:par>
+                        <p:par>
+                          <p:cTn id="19" fill="hold">
+                            <p:stCondLst>
+                              <p:cond delay="0"/>
+                            </p:stCondLst>
+                            <p:childTnLst>
+                              <p:set>
+                                <p:cBhvr>
+                                  <p:cTn id="20" dur="1" fill="hold">
+                                    <p:stCondLst>
+                                      <p:cond delay="0"/>
+                                    </p:stCondLst>
+                                  </p:cTn>
+                                  <p:tgtEl>
+                                    <p:spTgt spid="17"/>
+                                  </p:tgtEl>
+                                  <p:attrNameLst>
+                                    <p:attrName>style.visibility</p:attrName>
+                                  </p:attrNameLst>
+                                </p:cBhvr>
+                                <p:to>
+                                  <p:strVal val="visible"/>
+                                </p:to>
+                              </p:set>
+                              <p:animEffect transition="in" filter="fade">
+                                <p:cBhvr>
+                                  <p:cTn id="21" dur="400">
+                                    <p:stCondLst>
+                                      <p:cond delay="0"/>
+                                    </p:stCondLst>
+                                  </p:cTn>
+                                  <p:tgtEl>
+                                    <p:spTgt spid="17"/>
+                                  </p:tgtEl>
+                                </p:cBhvr>
+                              </p:animEffect>
+                            </p:childTnLst>
+                          </p:cTn>
+                        </p:par>
+                      </p:childTnLst>
+                    </p:cTn>
+                  </p:par>
+                  <p:par>
+                    <p:cTn id="22" fill="hold">
+                      <p:stCondLst>
+                        <p:cond delay="0"/>
+                      </p:stCondLst>
+                      <p:childTnLst>
+                        <p:par>
+                          <p:cTn id="23" fill="hold">
+                            <p:stCondLst>
+                              <p:cond delay="0"/>
+                            </p:stCondLst>
+                            <p:childTnLst>
+                              <p:set>
+                                <p:cBhvr>
+                                  <p:cTn id="24" dur="1" fill="hold">
+                                    <p:stCondLst>
+                                      <p:cond delay="0"/>
+                                    </p:stCondLst>
+                                  </p:cTn>
+                                  <p:tgtEl>
+                                    <p:spTgt spid="13"/>
+                                  </p:tgtEl>
+                                  <p:attrNameLst>
+                                    <p:attrName>style.visibility</p:attrName>
+                                  </p:attrNameLst>
+                                </p:cBhvr>
+                                <p:to>
+                                  <p:strVal val="visible"/>
+                                </p:to>
+                              </p:set>
+                              <p:animEffect transition="in" filter="fade">
+                                <p:cBhvr>
+                                  <p:cTn id="25" dur="400">
+                                    <p:stCondLst>
+                                      <p:cond delay="0"/>
+                                    </p:stCondLst>
+                                  </p:cTn>
+                                  <p:tgtEl>
+                                    <p:spTgt spid="13"/>
+                                  </p:tgtEl>
+                                </p:cBhvr>
+                              </p:animEffect>
+                            </p:childTnLst>
+                          </p:cTn>
+                        </p:par>
+                        <p:par>
+                          <p:cTn id="26" fill="hold">
+                            <p:stCondLst>
+                              <p:cond delay="0"/>
+                            </p:stCondLst>
+                            <p:childTnLst>
+                              <p:set>
+                                <p:cBhvr>
+                                  <p:cTn id="27" dur="1" fill="hold">
+                                    <p:stCondLst>
+                                      <p:cond delay="0"/>
+                                    </p:stCondLst>
+                                  </p:cTn>
+                                  <p:tgtEl>
+                                    <p:spTgt spid="14"/>
+                                  </p:tgtEl>
+                                  <p:attrNameLst>
+                                    <p:attrName>style.visibility</p:attrName>
+                                  </p:attrNameLst>
+                                </p:cBhvr>
+                                <p:to>
+                                  <p:strVal val="visible"/>
+                                </p:to>
+                              </p:set>
+                              <p:animEffect transition="in" filter="fade">
+                                <p:cBhvr>
+                                  <p:cTn id="28" dur="400">
+                                    <p:stCondLst>
+                                      <p:cond delay="0"/>
+                                    </p:stCondLst>
+                                  </p:cTn>
+                                  <p:tgtEl>
+                                    <p:spTgt spid="14"/>
+                                  </p:tgtEl>
+                                </p:cBhvr>
+                              </p:animEffect>
+                            </p:childTnLst>
+                          </p:cTn>
+                        </p:par>
+                        <p:par>
+                          <p:cTn id="29" fill="hold">
+                            <p:stCondLst>
+                              <p:cond delay="0"/>
+                            </p:stCondLst>
+                            <p:childTnLst>
+                              <p:set>
+                                <p:cBhvr>
+                                  <p:cTn id="30" dur="1" fill="hold">
+                                    <p:stCondLst>
+                                      <p:cond delay="0"/>
+                                    </p:stCondLst>
+                                  </p:cTn>
+                                  <p:tgtEl>
+                                    <p:spTgt spid="15"/>
+                                  </p:tgtEl>
+                                  <p:attrNameLst>
+                                    <p:attrName>style.visibility</p:attrName>
+                                  </p:attrNameLst>
+                                </p:cBhvr>
+                                <p:to>
+                                  <p:strVal val="visible"/>
+                                </p:to>
+                              </p:set>
+                              <p:animEffect transition="in" filter="fade">
+                                <p:cBhvr>
+                                  <p:cTn id="31" dur="400">
+                                    <p:stCondLst>
+                                      <p:cond delay="0"/>
+                                    </p:stCondLst>
+                                  </p:cTn>
+                                  <p:tgtEl>
+                                    <p:spTgt spid="15"/>
+                                  </p:tgtEl>
+                                </p:cBhvr>
+                              </p:animEffect>
+                            </p:childTnLst>
+                          </p:cTn>
+                        </p:par>
+                        <p:par>
+                          <p:cTn id="32" fill="hold">
+                            <p:stCondLst>
+                              <p:cond delay="0"/>
+                            </p:stCondLst>
+                            <p:childTnLst>
+                              <p:set>
+                                <p:cBhvr>
+                                  <p:cTn id="33" dur="1" fill="hold">
+                                    <p:stCondLst>
+                                      <p:cond delay="0"/>
+                                    </p:stCondLst>
+                                  </p:cTn>
+                                  <p:tgtEl>
+                                    <p:spTgt spid="16"/>
+                                  </p:tgtEl>
+                                  <p:attrNameLst>
+                                    <p:attrName>style.visibility</p:attrName>
+                                  </p:attrNameLst>
+                                </p:cBhvr>
+                                <p:to>
+                                  <p:strVal val="visible"/>
+                                </p:to>
+                              </p:set>
+                              <p:animEffect transition="in" filter="fade">
+                                <p:cBhvr>
+                                  <p:cTn id="34" dur="400">
+                                    <p:stCondLst>
+                                      <p:cond delay="0"/>
+                                    </p:stCondLst>
+                                  </p:cTn>
+                                  <p:tgtEl>
+                                    <p:spTgt spid="16"/>
+                                  </p:tgtEl>
+                                </p:cBhvr>
+                              </p:animEffect>
+                            </p:childTnLst>
+                          </p:cTn>
+                        </p:par>
+                        <p:par>
+                          <p:cTn id="35" fill="hold">
+                            <p:stCondLst>
+                              <p:cond delay="0"/>
+                            </p:stCondLst>
+                            <p:childTnLst>
+                              <p:set>
+                                <p:cBhvr>
+                                  <p:cTn id="36" dur="1" fill="hold">
+                                    <p:stCondLst>
+                                      <p:cond delay="0"/>
+                                    </p:stCondLst>
+                                  </p:cTn>
+                                  <p:tgtEl>
+                                    <p:spTgt spid="12"/>
+                                  </p:tgtEl>
+                                  <p:attrNameLst>
+                                    <p:attrName>style.visibility</p:attrName>
+                                  </p:attrNameLst>
+                                </p:cBhvr>
+                                <p:to>
+                                  <p:strVal val="visible"/>
+                                </p:to>
+                              </p:set>
+                              <p:animEffect transition="in" filter="fade">
+                                <p:cBhvr>
+                                  <p:cTn id="37" dur="400">
+                                    <p:stCondLst>
+                                      <p:cond delay="0"/>
+                                    </p:stCondLst>
+                                  </p:cTn>
+                                  <p:tgtEl>
+                                    <p:spTgt spid="12"/>
+                                  </p:tgtEl>
+                                </p:cBhvr>
+                              </p:animEffect>
+                            </p:childTnLst>
+                          </p:cTn>
+                        </p:par>
+                        <p:par>
+                          <p:cTn id="38" fill="hold">
+                            <p:stCondLst>
+                              <p:cond delay="0"/>
+                            </p:stCondLst>
+                            <p:childTnLst>
+                              <p:set>
+                                <p:cBhvr>
+                                  <p:cTn id="39" dur="1" fill="hold">
+                                    <p:stCondLst>
+                                      <p:cond delay="0"/>
+                                    </p:stCondLst>
+                                  </p:cTn>
+                                  <p:tgtEl>
+                                    <p:spTgt spid="11"/>
+                                  </p:tgtEl>
+                                  <p:attrNameLst>
+                                    <p:attrName>style.visibility</p:attrName>
+                                  </p:attrNameLst>
+                                </p:cBhvr>
+                                <p:to>
+                                  <p:strVal val="visible"/>
+                                </p:to>
+                              </p:set>
+                              <p:animEffect transition="in" filter="fade">
+                                <p:cBhvr>
+                                  <p:cTn id="40" dur="400">
+                                    <p:stCondLst>
+                                      <p:cond delay="0"/>
+                                    </p:stCondLst>
+                                  </p:cTn>
+                                  <p:tgtEl>
+                                    <p:spTgt spid="11"/>
+                                  </p:tgtEl>
+                                </p:cBhvr>
+                              </p:animEffect>
+                            </p:childTnLst>
+                          </p:cTn>
+                        </p:par>
+                      </p:childTnLst>
+                    </p:cTn>
+                  </p:par>
+                  <p:par>
+                    <p:cTn id="41" fill="hold">
+                      <p:stCondLst>
+                        <p:cond delay="0"/>
+                      </p:stCondLst>
+                      <p:childTnLst>
+                        <p:par>
+                          <p:cTn id="42" fill="hold">
+                            <p:stCondLst>
+                              <p:cond delay="0"/>
+                            </p:stCondLst>
+                            <p:childTnLst>
+                              <p:set>
+                                <p:cBhvr>
+                                  <p:cTn id="43" dur="1" fill="hold">
+                                    <p:stCondLst>
+                                      <p:cond delay="0"/>
+                                    </p:stCondLst>
+                                  </p:cTn>
+                                  <p:tgtEl>
+                                    <p:spTgt spid="7"/>
+                                  </p:tgtEl>
+                                  <p:attrNameLst>
+                                    <p:attrName>style.visibility</p:attrName>
+                                  </p:attrNameLst>
+                                </p:cBhvr>
+                                <p:to>
+                                  <p:strVal val="visible"/>
+                                </p:to>
+                              </p:set>
+                              <p:animEffect transition="in" filter="fade">
+                                <p:cBhvr>
+                                  <p:cTn id="44" dur="400">
+                                    <p:stCondLst>
+                                      <p:cond delay="0"/>
+                                    </p:stCondLst>
+                                  </p:cTn>
+                                  <p:tgtEl>
+                                    <p:spTgt spid="7"/>
+                                  </p:tgtEl>
+                                </p:cBhvr>
+                              </p:animEffect>
+                            </p:childTnLst>
+                          </p:cTn>
+                        </p:par>
+                        <p:par>
+                          <p:cTn id="45" fill="hold">
+                            <p:stCondLst>
+                              <p:cond delay="0"/>
+                            </p:stCondLst>
+                            <p:childTnLst>
+                              <p:set>
+                                <p:cBhvr>
+                                  <p:cTn id="46" dur="1" fill="hold">
+                                    <p:stCondLst>
+                                      <p:cond delay="0"/>
+                                    </p:stCondLst>
+                                  </p:cTn>
+                                  <p:tgtEl>
+                                    <p:spTgt spid="8"/>
+                                  </p:tgtEl>
+                                  <p:attrNameLst>
+                                    <p:attrName>style.visibility</p:attrName>
+                                  </p:attrNameLst>
+                                </p:cBhvr>
+                                <p:to>
+                                  <p:strVal val="visible"/>
+                                </p:to>
+                              </p:set>
+                              <p:animEffect transition="in" filter="fade">
+                                <p:cBhvr>
+                                  <p:cTn id="47" dur="400">
+                                    <p:stCondLst>
+                                      <p:cond delay="0"/>
+                                    </p:stCondLst>
+                                  </p:cTn>
+                                  <p:tgtEl>
+                                    <p:spTgt spid="8"/>
+                                  </p:tgtEl>
+                                </p:cBhvr>
+                              </p:animEffect>
+                            </p:childTnLst>
+                          </p:cTn>
+                        </p:par>
+                        <p:par>
+                          <p:cTn id="48" fill="hold">
+                            <p:stCondLst>
+                              <p:cond delay="0"/>
+                            </p:stCondLst>
+                            <p:childTnLst>
+                              <p:set>
+                                <p:cBhvr>
+                                  <p:cTn id="49" dur="1" fill="hold">
+                                    <p:stCondLst>
+                                      <p:cond delay="0"/>
+                                    </p:stCondLst>
+                                  </p:cTn>
+                                  <p:tgtEl>
+                                    <p:spTgt spid="9"/>
+                                  </p:tgtEl>
+                                  <p:attrNameLst>
+                                    <p:attrName>style.visibility</p:attrName>
+                                  </p:attrNameLst>
+                                </p:cBhvr>
+                                <p:to>
+                                  <p:strVal val="visible"/>
+                                </p:to>
+                              </p:set>
+                              <p:animEffect transition="in" filter="fade">
+                                <p:cBhvr>
+                                  <p:cTn id="50" dur="400">
+                                    <p:stCondLst>
+                                      <p:cond delay="0"/>
+                                    </p:stCondLst>
+                                  </p:cTn>
+                                  <p:tgtEl>
+                                    <p:spTgt spid="9"/>
+                                  </p:tgtEl>
+                                </p:cBhvr>
+                              </p:animEffect>
+                            </p:childTnLst>
+                          </p:cTn>
+                        </p:par>
+                        <p:par>
+                          <p:cTn id="51" fill="hold">
+                            <p:stCondLst>
+                              <p:cond delay="0"/>
+                            </p:stCondLst>
+                            <p:childTnLst>
+                              <p:set>
+                                <p:cBhvr>
+                                  <p:cTn id="52" dur="1" fill="hold">
+                                    <p:stCondLst>
+                                      <p:cond delay="0"/>
+                                    </p:stCondLst>
+                                  </p:cTn>
+                                  <p:tgtEl>
+                                    <p:spTgt spid="10"/>
+                                  </p:tgtEl>
+                                  <p:attrNameLst>
+                                    <p:attrName>style.visibility</p:attrName>
+                                  </p:attrNameLst>
+                                </p:cBhvr>
+                                <p:to>
+                                  <p:strVal val="visible"/>
+                                </p:to>
+                              </p:set>
+                              <p:animEffect transition="in" filter="fade">
+                                <p:cBhvr>
+                                  <p:cTn id="53" dur="400">
+                                    <p:stCondLst>
+                                      <p:cond delay="0"/>
+                                    </p:stCondLst>
+                                  </p:cTn>
+                                  <p:tgtEl>
+                                    <p:spTgt spid="10"/>
+                                  </p:tgtEl>
+                                </p:cBhvr>
+                              </p:animEffect>
+                            </p:childTnLst>
+                          </p:cTn>
+                        </p:par>
+                        <p:par>
+                          <p:cTn id="54" fill="hold">
+                            <p:stCondLst>
+                              <p:cond delay="0"/>
+                            </p:stCondLst>
+                            <p:childTnLst>
+                              <p:set>
+                                <p:cBhvr>
+                                  <p:cTn id="55" dur="1" fill="hold">
+                                    <p:stCondLst>
+                                      <p:cond delay="0"/>
+                                    </p:stCondLst>
+                                  </p:cTn>
+                                  <p:tgtEl>
+                                    <p:spTgt spid="6"/>
+                                  </p:tgtEl>
+                                  <p:attrNameLst>
+                                    <p:attrName>style.visibility</p:attrName>
+                                  </p:attrNameLst>
+                                </p:cBhvr>
+                                <p:to>
+                                  <p:strVal val="visible"/>
+                                </p:to>
+                              </p:set>
+                              <p:animEffect transition="in" filter="fade">
+                                <p:cBhvr>
+                                  <p:cTn id="56" dur="400">
+                                    <p:stCondLst>
+                                      <p:cond delay="0"/>
+                                    </p:stCondLst>
+                                  </p:cTn>
+                                  <p:tgtEl>
+                                    <p:spTgt spid="6"/>
+                                  </p:tgtEl>
+                                </p:cBhvr>
+                              </p:animEffect>
+                            </p:childTnLst>
+                          </p:cTn>
+                        </p:par>
+                        <p:par>
+                          <p:cTn id="57" fill="hold">
+                            <p:stCondLst>
+                              <p:cond delay="0"/>
+                            </p:stCondLst>
+                            <p:childTnLst>
+                              <p:set>
+                                <p:cBhvr>
+                                  <p:cTn id="58" dur="1" fill="hold">
+                                    <p:stCondLst>
+                                      <p:cond delay="0"/>
+                                    </p:stCondLst>
+                                  </p:cTn>
+                                  <p:tgtEl>
+                                    <p:spTgt spid="5"/>
+                                  </p:tgtEl>
+                                  <p:attrNameLst>
+                                    <p:attrName>style.visibility</p:attrName>
+                                  </p:attrNameLst>
+                                </p:cBhvr>
+                                <p:to>
+                                  <p:strVal val="visible"/>
+                                </p:to>
+                              </p:set>
+                              <p:animEffect transition="in" filter="fade">
+                                <p:cBhvr>
+                                  <p:cTn id="59" dur="400">
+                                    <p:stCondLst>
+                                      <p:cond delay="0"/>
+                                    </p:stCondLst>
+                                  </p:cTn>
+                                  <p:tgtEl>
+                                    <p:spTgt spid="5"/>
+                                  </p:tgtEl>
+                                </p:cBhvr>
+                              </p:animEffect>
+                            </p:childTnLst>
+                          </p:cTn>
+                        </p:par>
+                      </p:childTnLst>
+                    </p:cTn>
+                  </p:par>
+                </p:childTnLst>
+              </p:cTn>
+              <p:prevCondLst>
+                <p:cond evt="onPrev" delay="0"/>
+              </p:prevCondLst>
+              <p:nextCondLst>
+                <p:cond evt="onNext" delay="0"/>
+              </p:nextCondLst>
+            </p:seq>
+          </p:childTnLst>
+        </p:cTn>
+      </p:par>
+    </p:tnLst>
+  </p:timing>
 </p:sld>
 </file>
 
@@ -7106,6 +8140,376 @@
   <p:transition spd="fast" advClick="1">
     <p:fade/>
   </p:transition>
+  <p:timing>
+    <p:tnLst>
+      <p:par>
+        <p:cTn id="1" dur="indefinite" restart="always" nodeType="tmRoot">
+          <p:childTnLst>
+            <p:seq concurrent="1" nextAc="seek">
+              <p:cTn id="2" dur="indefinite" nodeType="mainSeq">
+                <p:childTnLst>
+                  <p:par>
+                    <p:cTn id="3" fill="hold">
+                      <p:stCondLst>
+                        <p:cond delay="0"/>
+                      </p:stCondLst>
+                      <p:childTnLst>
+                        <p:par>
+                          <p:cTn id="4" fill="hold">
+                            <p:stCondLst>
+                              <p:cond delay="0"/>
+                            </p:stCondLst>
+                            <p:childTnLst>
+                              <p:set>
+                                <p:cBhvr>
+                                  <p:cTn id="5" dur="1" fill="hold">
+                                    <p:stCondLst>
+                                      <p:cond delay="0"/>
+                                    </p:stCondLst>
+                                  </p:cTn>
+                                  <p:tgtEl>
+                                    <p:spTgt spid="5"/>
+                                  </p:tgtEl>
+                                  <p:attrNameLst>
+                                    <p:attrName>style.visibility</p:attrName>
+                                  </p:attrNameLst>
+                                </p:cBhvr>
+                                <p:to>
+                                  <p:strVal val="visible"/>
+                                </p:to>
+                              </p:set>
+                              <p:animEffect transition="in" filter="fade">
+                                <p:cBhvr>
+                                  <p:cTn id="6" dur="600">
+                                    <p:stCondLst>
+                                      <p:cond delay="0"/>
+                                    </p:stCondLst>
+                                  </p:cTn>
+                                  <p:tgtEl>
+                                    <p:spTgt spid="5"/>
+                                  </p:tgtEl>
+                                </p:cBhvr>
+                              </p:animEffect>
+                            </p:childTnLst>
+                          </p:cTn>
+                        </p:par>
+                        <p:par>
+                          <p:cTn id="7" fill="hold">
+                            <p:stCondLst>
+                              <p:cond delay="0"/>
+                            </p:stCondLst>
+                            <p:childTnLst>
+                              <p:set>
+                                <p:cBhvr>
+                                  <p:cTn id="8" dur="1" fill="hold">
+                                    <p:stCondLst>
+                                      <p:cond delay="0"/>
+                                    </p:stCondLst>
+                                  </p:cTn>
+                                  <p:tgtEl>
+                                    <p:spTgt spid="6"/>
+                                  </p:tgtEl>
+                                  <p:attrNameLst>
+                                    <p:attrName>style.visibility</p:attrName>
+                                  </p:attrNameLst>
+                                </p:cBhvr>
+                                <p:to>
+                                  <p:strVal val="visible"/>
+                                </p:to>
+                              </p:set>
+                              <p:animEffect transition="in" filter="fade">
+                                <p:cBhvr>
+                                  <p:cTn id="9" dur="600">
+                                    <p:stCondLst>
+                                      <p:cond delay="0"/>
+                                    </p:stCondLst>
+                                  </p:cTn>
+                                  <p:tgtEl>
+                                    <p:spTgt spid="6"/>
+                                  </p:tgtEl>
+                                </p:cBhvr>
+                              </p:animEffect>
+                            </p:childTnLst>
+                          </p:cTn>
+                        </p:par>
+                      </p:childTnLst>
+                    </p:cTn>
+                  </p:par>
+                  <p:par>
+                    <p:cTn id="10" fill="hold">
+                      <p:stCondLst>
+                        <p:cond delay="0"/>
+                      </p:stCondLst>
+                      <p:childTnLst>
+                        <p:par>
+                          <p:cTn id="11" fill="hold">
+                            <p:stCondLst>
+                              <p:cond delay="0"/>
+                            </p:stCondLst>
+                            <p:childTnLst>
+                              <p:set>
+                                <p:cBhvr>
+                                  <p:cTn id="12" dur="1" fill="hold">
+                                    <p:stCondLst>
+                                      <p:cond delay="0"/>
+                                    </p:stCondLst>
+                                  </p:cTn>
+                                  <p:tgtEl>
+                                    <p:spTgt spid="7"/>
+                                  </p:tgtEl>
+                                  <p:attrNameLst>
+                                    <p:attrName>style.visibility</p:attrName>
+                                  </p:attrNameLst>
+                                </p:cBhvr>
+                                <p:to>
+                                  <p:strVal val="visible"/>
+                                </p:to>
+                              </p:set>
+                              <p:animEffect transition="in" filter="fade">
+                                <p:cBhvr>
+                                  <p:cTn id="13" dur="600">
+                                    <p:stCondLst>
+                                      <p:cond delay="0"/>
+                                    </p:stCondLst>
+                                  </p:cTn>
+                                  <p:tgtEl>
+                                    <p:spTgt spid="7"/>
+                                  </p:tgtEl>
+                                </p:cBhvr>
+                              </p:animEffect>
+                            </p:childTnLst>
+                          </p:cTn>
+                        </p:par>
+                        <p:par>
+                          <p:cTn id="14" fill="hold">
+                            <p:stCondLst>
+                              <p:cond delay="0"/>
+                            </p:stCondLst>
+                            <p:childTnLst>
+                              <p:set>
+                                <p:cBhvr>
+                                  <p:cTn id="15" dur="1" fill="hold">
+                                    <p:stCondLst>
+                                      <p:cond delay="0"/>
+                                    </p:stCondLst>
+                                  </p:cTn>
+                                  <p:tgtEl>
+                                    <p:spTgt spid="8"/>
+                                  </p:tgtEl>
+                                  <p:attrNameLst>
+                                    <p:attrName>style.visibility</p:attrName>
+                                  </p:attrNameLst>
+                                </p:cBhvr>
+                                <p:to>
+                                  <p:strVal val="visible"/>
+                                </p:to>
+                              </p:set>
+                              <p:animEffect transition="in" filter="fade">
+                                <p:cBhvr>
+                                  <p:cTn id="16" dur="600">
+                                    <p:stCondLst>
+                                      <p:cond delay="0"/>
+                                    </p:stCondLst>
+                                  </p:cTn>
+                                  <p:tgtEl>
+                                    <p:spTgt spid="8"/>
+                                  </p:tgtEl>
+                                </p:cBhvr>
+                              </p:animEffect>
+                            </p:childTnLst>
+                          </p:cTn>
+                        </p:par>
+                      </p:childTnLst>
+                    </p:cTn>
+                  </p:par>
+                  <p:par>
+                    <p:cTn id="17" fill="hold">
+                      <p:stCondLst>
+                        <p:cond delay="0"/>
+                      </p:stCondLst>
+                      <p:childTnLst>
+                        <p:par>
+                          <p:cTn id="18" fill="hold">
+                            <p:stCondLst>
+                              <p:cond delay="0"/>
+                            </p:stCondLst>
+                            <p:childTnLst>
+                              <p:set>
+                                <p:cBhvr>
+                                  <p:cTn id="19" dur="1" fill="hold">
+                                    <p:stCondLst>
+                                      <p:cond delay="0"/>
+                                    </p:stCondLst>
+                                  </p:cTn>
+                                  <p:tgtEl>
+                                    <p:spTgt spid="9"/>
+                                  </p:tgtEl>
+                                  <p:attrNameLst>
+                                    <p:attrName>style.visibility</p:attrName>
+                                  </p:attrNameLst>
+                                </p:cBhvr>
+                                <p:to>
+                                  <p:strVal val="visible"/>
+                                </p:to>
+                              </p:set>
+                              <p:animEffect transition="in" filter="fade">
+                                <p:cBhvr>
+                                  <p:cTn id="20" dur="600">
+                                    <p:stCondLst>
+                                      <p:cond delay="0"/>
+                                    </p:stCondLst>
+                                  </p:cTn>
+                                  <p:tgtEl>
+                                    <p:spTgt spid="9"/>
+                                  </p:tgtEl>
+                                </p:cBhvr>
+                              </p:animEffect>
+                            </p:childTnLst>
+                          </p:cTn>
+                        </p:par>
+                        <p:par>
+                          <p:cTn id="21" fill="hold">
+                            <p:stCondLst>
+                              <p:cond delay="0"/>
+                            </p:stCondLst>
+                            <p:childTnLst>
+                              <p:set>
+                                <p:cBhvr>
+                                  <p:cTn id="22" dur="1" fill="hold">
+                                    <p:stCondLst>
+                                      <p:cond delay="0"/>
+                                    </p:stCondLst>
+                                  </p:cTn>
+                                  <p:tgtEl>
+                                    <p:spTgt spid="10"/>
+                                  </p:tgtEl>
+                                  <p:attrNameLst>
+                                    <p:attrName>style.visibility</p:attrName>
+                                  </p:attrNameLst>
+                                </p:cBhvr>
+                                <p:to>
+                                  <p:strVal val="visible"/>
+                                </p:to>
+                              </p:set>
+                              <p:animEffect transition="in" filter="fade">
+                                <p:cBhvr>
+                                  <p:cTn id="23" dur="600">
+                                    <p:stCondLst>
+                                      <p:cond delay="0"/>
+                                    </p:stCondLst>
+                                  </p:cTn>
+                                  <p:tgtEl>
+                                    <p:spTgt spid="10"/>
+                                  </p:tgtEl>
+                                </p:cBhvr>
+                              </p:animEffect>
+                            </p:childTnLst>
+                          </p:cTn>
+                        </p:par>
+                      </p:childTnLst>
+                    </p:cTn>
+                  </p:par>
+                  <p:par>
+                    <p:cTn id="24" fill="hold">
+                      <p:stCondLst>
+                        <p:cond delay="0"/>
+                      </p:stCondLst>
+                      <p:childTnLst>
+                        <p:par>
+                          <p:cTn id="25" fill="hold">
+                            <p:stCondLst>
+                              <p:cond delay="0"/>
+                            </p:stCondLst>
+                            <p:childTnLst>
+                              <p:set>
+                                <p:cBhvr>
+                                  <p:cTn id="26" dur="1" fill="hold">
+                                    <p:stCondLst>
+                                      <p:cond delay="0"/>
+                                    </p:stCondLst>
+                                  </p:cTn>
+                                  <p:tgtEl>
+                                    <p:spTgt spid="11"/>
+                                  </p:tgtEl>
+                                  <p:attrNameLst>
+                                    <p:attrName>style.visibility</p:attrName>
+                                  </p:attrNameLst>
+                                </p:cBhvr>
+                                <p:to>
+                                  <p:strVal val="visible"/>
+                                </p:to>
+                              </p:set>
+                              <p:animEffect transition="in" filter="fade">
+                                <p:cBhvr>
+                                  <p:cTn id="27" dur="600">
+                                    <p:stCondLst>
+                                      <p:cond delay="0"/>
+                                    </p:stCondLst>
+                                  </p:cTn>
+                                  <p:tgtEl>
+                                    <p:spTgt spid="11"/>
+                                  </p:tgtEl>
+                                </p:cBhvr>
+                              </p:animEffect>
+                            </p:childTnLst>
+                          </p:cTn>
+                        </p:par>
+                        <p:par>
+                          <p:cTn id="28" fill="hold">
+                            <p:stCondLst>
+                              <p:cond delay="0"/>
+                            </p:stCondLst>
+                            <p:childTnLst>
+                              <p:set>
+                                <p:cBhvr>
+                                  <p:cTn id="29" dur="1" fill="hold">
+                                    <p:stCondLst>
+                                      <p:cond delay="0"/>
+                                    </p:stCondLst>
+                                  </p:cTn>
+                                  <p:tgtEl>
+                                    <p:spTgt spid="12"/>
+                                  </p:tgtEl>
+                                  <p:attrNameLst>
+                                    <p:attrName>style.visibility</p:attrName>
+                                  </p:attrNameLst>
+                                </p:cBhvr>
+                                <p:to>
+                                  <p:strVal val="visible"/>
+                                </p:to>
+                              </p:set>
+                              <p:animEffect transition="in" filter="fade">
+                                <p:cBhvr>
+                                  <p:cTn id="30" dur="600">
+                                    <p:stCondLst>
+                                      <p:cond delay="0"/>
+                                    </p:stCondLst>
+                                  </p:cTn>
+                                  <p:tgtEl>
+                                    <p:spTgt spid="12"/>
+                                  </p:tgtEl>
+                                </p:cBhvr>
+                              </p:animEffect>
+                            </p:childTnLst>
+                          </p:cTn>
+                        </p:par>
+                      </p:childTnLst>
+                    </p:cTn>
+                  </p:par>
+                </p:childTnLst>
+              </p:cTn>
+              <p:prevCondLst>
+                <p:cond evt="onPrev" delay="0"/>
+              </p:prevCondLst>
+              <p:nextCondLst>
+                <p:cond evt="onNext" delay="0"/>
+              </p:nextCondLst>
+            </p:seq>
+          </p:childTnLst>
+        </p:cTn>
+      </p:par>
+    </p:tnLst>
+  </p:timing>
 </p:sld>
 </file>
 
@@ -9248,6 +10652,607 @@
   <p:transition spd="fast" advClick="1">
     <p:fade/>
   </p:transition>
+  <p:timing>
+    <p:tnLst>
+      <p:par>
+        <p:cTn id="1" dur="indefinite" restart="always" nodeType="tmRoot">
+          <p:childTnLst>
+            <p:seq concurrent="1" nextAc="seek">
+              <p:cTn id="2" dur="indefinite" nodeType="mainSeq">
+                <p:childTnLst>
+                  <p:par>
+                    <p:cTn id="3" fill="hold">
+                      <p:stCondLst>
+                        <p:cond delay="0"/>
+                      </p:stCondLst>
+                      <p:childTnLst>
+                        <p:par>
+                          <p:cTn id="4" fill="hold">
+                            <p:stCondLst>
+                              <p:cond delay="0"/>
+                            </p:stCondLst>
+                            <p:childTnLst>
+                              <p:set>
+                                <p:cBhvr>
+                                  <p:cTn id="5" dur="1" fill="hold">
+                                    <p:stCondLst>
+                                      <p:cond delay="0"/>
+                                    </p:stCondLst>
+                                  </p:cTn>
+                                  <p:tgtEl>
+                                    <p:spTgt spid="7"/>
+                                  </p:tgtEl>
+                                  <p:attrNameLst>
+                                    <p:attrName>style.visibility</p:attrName>
+                                  </p:attrNameLst>
+                                </p:cBhvr>
+                                <p:to>
+                                  <p:strVal val="visible"/>
+                                </p:to>
+                              </p:set>
+                              <p:animEffect transition="in" filter="fade">
+                                <p:cBhvr>
+                                  <p:cTn id="6" dur="400">
+                                    <p:stCondLst>
+                                      <p:cond delay="0"/>
+                                    </p:stCondLst>
+                                  </p:cTn>
+                                  <p:tgtEl>
+                                    <p:spTgt spid="7"/>
+                                  </p:tgtEl>
+                                </p:cBhvr>
+                              </p:animEffect>
+                            </p:childTnLst>
+                          </p:cTn>
+                        </p:par>
+                        <p:par>
+                          <p:cTn id="7" fill="hold">
+                            <p:stCondLst>
+                              <p:cond delay="0"/>
+                            </p:stCondLst>
+                            <p:childTnLst>
+                              <p:set>
+                                <p:cBhvr>
+                                  <p:cTn id="8" dur="1" fill="hold">
+                                    <p:stCondLst>
+                                      <p:cond delay="0"/>
+                                    </p:stCondLst>
+                                  </p:cTn>
+                                  <p:tgtEl>
+                                    <p:spTgt spid="8"/>
+                                  </p:tgtEl>
+                                  <p:attrNameLst>
+                                    <p:attrName>style.visibility</p:attrName>
+                                  </p:attrNameLst>
+                                </p:cBhvr>
+                                <p:to>
+                                  <p:strVal val="visible"/>
+                                </p:to>
+                              </p:set>
+                              <p:animEffect transition="in" filter="fade">
+                                <p:cBhvr>
+                                  <p:cTn id="9" dur="400">
+                                    <p:stCondLst>
+                                      <p:cond delay="0"/>
+                                    </p:stCondLst>
+                                  </p:cTn>
+                                  <p:tgtEl>
+                                    <p:spTgt spid="8"/>
+                                  </p:tgtEl>
+                                </p:cBhvr>
+                              </p:animEffect>
+                            </p:childTnLst>
+                          </p:cTn>
+                        </p:par>
+                        <p:par>
+                          <p:cTn id="10" fill="hold">
+                            <p:stCondLst>
+                              <p:cond delay="0"/>
+                            </p:stCondLst>
+                            <p:childTnLst>
+                              <p:set>
+                                <p:cBhvr>
+                                  <p:cTn id="11" dur="1" fill="hold">
+                                    <p:stCondLst>
+                                      <p:cond delay="0"/>
+                                    </p:stCondLst>
+                                  </p:cTn>
+                                  <p:tgtEl>
+                                    <p:spTgt spid="5"/>
+                                  </p:tgtEl>
+                                  <p:attrNameLst>
+                                    <p:attrName>style.visibility</p:attrName>
+                                  </p:attrNameLst>
+                                </p:cBhvr>
+                                <p:to>
+                                  <p:strVal val="visible"/>
+                                </p:to>
+                              </p:set>
+                              <p:animEffect transition="in" filter="fade">
+                                <p:cBhvr>
+                                  <p:cTn id="12" dur="400">
+                                    <p:stCondLst>
+                                      <p:cond delay="0"/>
+                                    </p:stCondLst>
+                                  </p:cTn>
+                                  <p:tgtEl>
+                                    <p:spTgt spid="5"/>
+                                  </p:tgtEl>
+                                </p:cBhvr>
+                              </p:animEffect>
+                            </p:childTnLst>
+                          </p:cTn>
+                        </p:par>
+                      </p:childTnLst>
+                    </p:cTn>
+                  </p:par>
+                  <p:par>
+                    <p:cTn id="13" fill="hold">
+                      <p:stCondLst>
+                        <p:cond delay="0"/>
+                      </p:stCondLst>
+                      <p:childTnLst>
+                        <p:par>
+                          <p:cTn id="14" fill="hold">
+                            <p:stCondLst>
+                              <p:cond delay="0"/>
+                            </p:stCondLst>
+                            <p:childTnLst>
+                              <p:set>
+                                <p:cBhvr>
+                                  <p:cTn id="15" dur="1" fill="hold">
+                                    <p:stCondLst>
+                                      <p:cond delay="0"/>
+                                    </p:stCondLst>
+                                  </p:cTn>
+                                  <p:tgtEl>
+                                    <p:spTgt spid="6"/>
+                                  </p:tgtEl>
+                                  <p:attrNameLst>
+                                    <p:attrName>style.visibility</p:attrName>
+                                  </p:attrNameLst>
+                                </p:cBhvr>
+                                <p:to>
+                                  <p:strVal val="visible"/>
+                                </p:to>
+                              </p:set>
+                              <p:animEffect transition="in" filter="fade">
+                                <p:cBhvr>
+                                  <p:cTn id="16" dur="400">
+                                    <p:stCondLst>
+                                      <p:cond delay="0"/>
+                                    </p:stCondLst>
+                                  </p:cTn>
+                                  <p:tgtEl>
+                                    <p:spTgt spid="6"/>
+                                  </p:tgtEl>
+                                </p:cBhvr>
+                              </p:animEffect>
+                            </p:childTnLst>
+                          </p:cTn>
+                        </p:par>
+                      </p:childTnLst>
+                    </p:cTn>
+                  </p:par>
+                  <p:par>
+                    <p:cTn id="17" fill="hold">
+                      <p:stCondLst>
+                        <p:cond delay="0"/>
+                      </p:stCondLst>
+                      <p:childTnLst>
+                        <p:par>
+                          <p:cTn id="18" fill="hold">
+                            <p:stCondLst>
+                              <p:cond delay="0"/>
+                            </p:stCondLst>
+                            <p:childTnLst>
+                              <p:set>
+                                <p:cBhvr>
+                                  <p:cTn id="19" dur="1" fill="hold">
+                                    <p:stCondLst>
+                                      <p:cond delay="0"/>
+                                    </p:stCondLst>
+                                  </p:cTn>
+                                  <p:tgtEl>
+                                    <p:spTgt spid="10"/>
+                                  </p:tgtEl>
+                                  <p:attrNameLst>
+                                    <p:attrName>style.visibility</p:attrName>
+                                  </p:attrNameLst>
+                                </p:cBhvr>
+                                <p:to>
+                                  <p:strVal val="visible"/>
+                                </p:to>
+                              </p:set>
+                              <p:animEffect transition="in" filter="fade">
+                                <p:cBhvr>
+                                  <p:cTn id="20" dur="400">
+                                    <p:stCondLst>
+                                      <p:cond delay="0"/>
+                                    </p:stCondLst>
+                                  </p:cTn>
+                                  <p:tgtEl>
+                                    <p:spTgt spid="10"/>
+                                  </p:tgtEl>
+                                </p:cBhvr>
+                              </p:animEffect>
+                            </p:childTnLst>
+                          </p:cTn>
+                        </p:par>
+                        <p:par>
+                          <p:cTn id="21" fill="hold">
+                            <p:stCondLst>
+                              <p:cond delay="0"/>
+                            </p:stCondLst>
+                            <p:childTnLst>
+                              <p:set>
+                                <p:cBhvr>
+                                  <p:cTn id="22" dur="1" fill="hold">
+                                    <p:stCondLst>
+                                      <p:cond delay="0"/>
+                                    </p:stCondLst>
+                                  </p:cTn>
+                                  <p:tgtEl>
+                                    <p:spTgt spid="11"/>
+                                  </p:tgtEl>
+                                  <p:attrNameLst>
+                                    <p:attrName>style.visibility</p:attrName>
+                                  </p:attrNameLst>
+                                </p:cBhvr>
+                                <p:to>
+                                  <p:strVal val="visible"/>
+                                </p:to>
+                              </p:set>
+                              <p:animEffect transition="in" filter="fade">
+                                <p:cBhvr>
+                                  <p:cTn id="23" dur="400">
+                                    <p:stCondLst>
+                                      <p:cond delay="0"/>
+                                    </p:stCondLst>
+                                  </p:cTn>
+                                  <p:tgtEl>
+                                    <p:spTgt spid="11"/>
+                                  </p:tgtEl>
+                                </p:cBhvr>
+                              </p:animEffect>
+                            </p:childTnLst>
+                          </p:cTn>
+                        </p:par>
+                      </p:childTnLst>
+                    </p:cTn>
+                  </p:par>
+                  <p:par>
+                    <p:cTn id="24" fill="hold">
+                      <p:stCondLst>
+                        <p:cond delay="0"/>
+                      </p:stCondLst>
+                      <p:childTnLst>
+                        <p:par>
+                          <p:cTn id="25" fill="hold">
+                            <p:stCondLst>
+                              <p:cond delay="0"/>
+                            </p:stCondLst>
+                            <p:childTnLst>
+                              <p:set>
+                                <p:cBhvr>
+                                  <p:cTn id="26" dur="1" fill="hold">
+                                    <p:stCondLst>
+                                      <p:cond delay="0"/>
+                                    </p:stCondLst>
+                                  </p:cTn>
+                                  <p:tgtEl>
+                                    <p:spTgt spid="9"/>
+                                  </p:tgtEl>
+                                  <p:attrNameLst>
+                                    <p:attrName>style.visibility</p:attrName>
+                                  </p:attrNameLst>
+                                </p:cBhvr>
+                                <p:to>
+                                  <p:strVal val="visible"/>
+                                </p:to>
+                              </p:set>
+                              <p:animEffect transition="in" filter="fade">
+                                <p:cBhvr>
+                                  <p:cTn id="27" dur="400">
+                                    <p:stCondLst>
+                                      <p:cond delay="0"/>
+                                    </p:stCondLst>
+                                  </p:cTn>
+                                  <p:tgtEl>
+                                    <p:spTgt spid="9"/>
+                                  </p:tgtEl>
+                                </p:cBhvr>
+                              </p:animEffect>
+                            </p:childTnLst>
+                          </p:cTn>
+                        </p:par>
+                      </p:childTnLst>
+                    </p:cTn>
+                  </p:par>
+                  <p:par>
+                    <p:cTn id="28" fill="hold">
+                      <p:stCondLst>
+                        <p:cond delay="0"/>
+                      </p:stCondLst>
+                      <p:childTnLst>
+                        <p:par>
+                          <p:cTn id="29" fill="hold">
+                            <p:stCondLst>
+                              <p:cond delay="0"/>
+                            </p:stCondLst>
+                            <p:childTnLst>
+                              <p:set>
+                                <p:cBhvr>
+                                  <p:cTn id="30" dur="1" fill="hold">
+                                    <p:stCondLst>
+                                      <p:cond delay="0"/>
+                                    </p:stCondLst>
+                                  </p:cTn>
+                                  <p:tgtEl>
+                                    <p:spTgt spid="13"/>
+                                  </p:tgtEl>
+                                  <p:attrNameLst>
+                                    <p:attrName>style.visibility</p:attrName>
+                                  </p:attrNameLst>
+                                </p:cBhvr>
+                                <p:to>
+                                  <p:strVal val="visible"/>
+                                </p:to>
+                              </p:set>
+                              <p:animEffect transition="in" filter="fade">
+                                <p:cBhvr>
+                                  <p:cTn id="31" dur="400">
+                                    <p:stCondLst>
+                                      <p:cond delay="0"/>
+                                    </p:stCondLst>
+                                  </p:cTn>
+                                  <p:tgtEl>
+                                    <p:spTgt spid="13"/>
+                                  </p:tgtEl>
+                                </p:cBhvr>
+                              </p:animEffect>
+                            </p:childTnLst>
+                          </p:cTn>
+                        </p:par>
+                        <p:par>
+                          <p:cTn id="32" fill="hold">
+                            <p:stCondLst>
+                              <p:cond delay="0"/>
+                            </p:stCondLst>
+                            <p:childTnLst>
+                              <p:set>
+                                <p:cBhvr>
+                                  <p:cTn id="33" dur="1" fill="hold">
+                                    <p:stCondLst>
+                                      <p:cond delay="0"/>
+                                    </p:stCondLst>
+                                  </p:cTn>
+                                  <p:tgtEl>
+                                    <p:spTgt spid="14"/>
+                                  </p:tgtEl>
+                                  <p:attrNameLst>
+                                    <p:attrName>style.visibility</p:attrName>
+                                  </p:attrNameLst>
+                                </p:cBhvr>
+                                <p:to>
+                                  <p:strVal val="visible"/>
+                                </p:to>
+                              </p:set>
+                              <p:animEffect transition="in" filter="fade">
+                                <p:cBhvr>
+                                  <p:cTn id="34" dur="400">
+                                    <p:stCondLst>
+                                      <p:cond delay="0"/>
+                                    </p:stCondLst>
+                                  </p:cTn>
+                                  <p:tgtEl>
+                                    <p:spTgt spid="14"/>
+                                  </p:tgtEl>
+                                </p:cBhvr>
+                              </p:animEffect>
+                            </p:childTnLst>
+                          </p:cTn>
+                        </p:par>
+                      </p:childTnLst>
+                    </p:cTn>
+                  </p:par>
+                  <p:par>
+                    <p:cTn id="35" fill="hold">
+                      <p:stCondLst>
+                        <p:cond delay="0"/>
+                      </p:stCondLst>
+                      <p:childTnLst>
+                        <p:par>
+                          <p:cTn id="36" fill="hold">
+                            <p:stCondLst>
+                              <p:cond delay="0"/>
+                            </p:stCondLst>
+                            <p:childTnLst>
+                              <p:set>
+                                <p:cBhvr>
+                                  <p:cTn id="37" dur="1" fill="hold">
+                                    <p:stCondLst>
+                                      <p:cond delay="0"/>
+                                    </p:stCondLst>
+                                  </p:cTn>
+                                  <p:tgtEl>
+                                    <p:spTgt spid="12"/>
+                                  </p:tgtEl>
+                                  <p:attrNameLst>
+                                    <p:attrName>style.visibility</p:attrName>
+                                  </p:attrNameLst>
+                                </p:cBhvr>
+                                <p:to>
+                                  <p:strVal val="visible"/>
+                                </p:to>
+                              </p:set>
+                              <p:animEffect transition="in" filter="fade">
+                                <p:cBhvr>
+                                  <p:cTn id="38" dur="400">
+                                    <p:stCondLst>
+                                      <p:cond delay="0"/>
+                                    </p:stCondLst>
+                                  </p:cTn>
+                                  <p:tgtEl>
+                                    <p:spTgt spid="12"/>
+                                  </p:tgtEl>
+                                </p:cBhvr>
+                              </p:animEffect>
+                            </p:childTnLst>
+                          </p:cTn>
+                        </p:par>
+                      </p:childTnLst>
+                    </p:cTn>
+                  </p:par>
+                  <p:par>
+                    <p:cTn id="39" fill="hold">
+                      <p:stCondLst>
+                        <p:cond delay="0"/>
+                      </p:stCondLst>
+                      <p:childTnLst>
+                        <p:par>
+                          <p:cTn id="40" fill="hold">
+                            <p:stCondLst>
+                              <p:cond delay="0"/>
+                            </p:stCondLst>
+                            <p:childTnLst>
+                              <p:set>
+                                <p:cBhvr>
+                                  <p:cTn id="41" dur="1" fill="hold">
+                                    <p:stCondLst>
+                                      <p:cond delay="0"/>
+                                    </p:stCondLst>
+                                  </p:cTn>
+                                  <p:tgtEl>
+                                    <p:spTgt spid="16"/>
+                                  </p:tgtEl>
+                                  <p:attrNameLst>
+                                    <p:attrName>style.visibility</p:attrName>
+                                  </p:attrNameLst>
+                                </p:cBhvr>
+                                <p:to>
+                                  <p:strVal val="visible"/>
+                                </p:to>
+                              </p:set>
+                              <p:animEffect transition="in" filter="fade">
+                                <p:cBhvr>
+                                  <p:cTn id="42" dur="400">
+                                    <p:stCondLst>
+                                      <p:cond delay="0"/>
+                                    </p:stCondLst>
+                                  </p:cTn>
+                                  <p:tgtEl>
+                                    <p:spTgt spid="16"/>
+                                  </p:tgtEl>
+                                </p:cBhvr>
+                              </p:animEffect>
+                            </p:childTnLst>
+                          </p:cTn>
+                        </p:par>
+                        <p:par>
+                          <p:cTn id="43" fill="hold">
+                            <p:stCondLst>
+                              <p:cond delay="0"/>
+                            </p:stCondLst>
+                            <p:childTnLst>
+                              <p:set>
+                                <p:cBhvr>
+                                  <p:cTn id="44" dur="1" fill="hold">
+                                    <p:stCondLst>
+                                      <p:cond delay="0"/>
+                                    </p:stCondLst>
+                                  </p:cTn>
+                                  <p:tgtEl>
+                                    <p:spTgt spid="17"/>
+                                  </p:tgtEl>
+                                  <p:attrNameLst>
+                                    <p:attrName>style.visibility</p:attrName>
+                                  </p:attrNameLst>
+                                </p:cBhvr>
+                                <p:to>
+                                  <p:strVal val="visible"/>
+                                </p:to>
+                              </p:set>
+                              <p:animEffect transition="in" filter="fade">
+                                <p:cBhvr>
+                                  <p:cTn id="45" dur="400">
+                                    <p:stCondLst>
+                                      <p:cond delay="0"/>
+                                    </p:stCondLst>
+                                  </p:cTn>
+                                  <p:tgtEl>
+                                    <p:spTgt spid="17"/>
+                                  </p:tgtEl>
+                                </p:cBhvr>
+                              </p:animEffect>
+                            </p:childTnLst>
+                          </p:cTn>
+                        </p:par>
+                      </p:childTnLst>
+                    </p:cTn>
+                  </p:par>
+                  <p:par>
+                    <p:cTn id="46" fill="hold">
+                      <p:stCondLst>
+                        <p:cond delay="0"/>
+                      </p:stCondLst>
+                      <p:childTnLst>
+                        <p:par>
+                          <p:cTn id="47" fill="hold">
+                            <p:stCondLst>
+                              <p:cond delay="0"/>
+                            </p:stCondLst>
+                            <p:childTnLst>
+                              <p:set>
+                                <p:cBhvr>
+                                  <p:cTn id="48" dur="1" fill="hold">
+                                    <p:stCondLst>
+                                      <p:cond delay="0"/>
+                                    </p:stCondLst>
+                                  </p:cTn>
+                                  <p:tgtEl>
+                                    <p:spTgt spid="15"/>
+                                  </p:tgtEl>
+                                  <p:attrNameLst>
+                                    <p:attrName>style.visibility</p:attrName>
+                                  </p:attrNameLst>
+                                </p:cBhvr>
+                                <p:to>
+                                  <p:strVal val="visible"/>
+                                </p:to>
+                              </p:set>
+                              <p:animEffect transition="in" filter="fade">
+                                <p:cBhvr>
+                                  <p:cTn id="49" dur="400">
+                                    <p:stCondLst>
+                                      <p:cond delay="0"/>
+                                    </p:stCondLst>
+                                  </p:cTn>
+                                  <p:tgtEl>
+                                    <p:spTgt spid="15"/>
+                                  </p:tgtEl>
+                                </p:cBhvr>
+                              </p:animEffect>
+                            </p:childTnLst>
+                          </p:cTn>
+                        </p:par>
+                      </p:childTnLst>
+                    </p:cTn>
+                  </p:par>
+                </p:childTnLst>
+              </p:cTn>
+              <p:prevCondLst>
+                <p:cond evt="onPrev" delay="0"/>
+              </p:prevCondLst>
+              <p:nextCondLst>
+                <p:cond evt="onNext" delay="0"/>
+              </p:nextCondLst>
+            </p:seq>
+          </p:childTnLst>
+        </p:cTn>
+      </p:par>
+    </p:tnLst>
+  </p:timing>
 </p:sld>
 </file>
 
@@ -9992,6 +11997,514 @@
   <p:transition spd="fast" advClick="1">
     <p:fade/>
   </p:transition>
+  <p:timing>
+    <p:tnLst>
+      <p:par>
+        <p:cTn id="1" dur="indefinite" restart="always" nodeType="tmRoot">
+          <p:childTnLst>
+            <p:seq concurrent="1" nextAc="seek">
+              <p:cTn id="2" dur="indefinite" nodeType="mainSeq">
+                <p:childTnLst>
+                  <p:par>
+                    <p:cTn id="3" fill="hold">
+                      <p:stCondLst>
+                        <p:cond delay="0"/>
+                      </p:stCondLst>
+                      <p:childTnLst>
+                        <p:par>
+                          <p:cTn id="4" fill="hold">
+                            <p:stCondLst>
+                              <p:cond delay="0"/>
+                            </p:stCondLst>
+                            <p:childTnLst>
+                              <p:set>
+                                <p:cBhvr>
+                                  <p:cTn id="5" dur="1" fill="hold">
+                                    <p:stCondLst>
+                                      <p:cond delay="0"/>
+                                    </p:stCondLst>
+                                  </p:cTn>
+                                  <p:tgtEl>
+                                    <p:spTgt spid="5"/>
+                                  </p:tgtEl>
+                                  <p:attrNameLst>
+                                    <p:attrName>style.visibility</p:attrName>
+                                  </p:attrNameLst>
+                                </p:cBhvr>
+                                <p:to>
+                                  <p:strVal val="visible"/>
+                                </p:to>
+                              </p:set>
+                              <p:animEffect transition="in" filter="fade">
+                                <p:cBhvr>
+                                  <p:cTn id="6" dur="350">
+                                    <p:stCondLst>
+                                      <p:cond delay="0"/>
+                                    </p:stCondLst>
+                                  </p:cTn>
+                                  <p:tgtEl>
+                                    <p:spTgt spid="5"/>
+                                  </p:tgtEl>
+                                </p:cBhvr>
+                              </p:animEffect>
+                            </p:childTnLst>
+                          </p:cTn>
+                        </p:par>
+                        <p:par>
+                          <p:cTn id="7" fill="hold">
+                            <p:stCondLst>
+                              <p:cond delay="0"/>
+                            </p:stCondLst>
+                            <p:childTnLst>
+                              <p:set>
+                                <p:cBhvr>
+                                  <p:cTn id="8" dur="1" fill="hold">
+                                    <p:stCondLst>
+                                      <p:cond delay="0"/>
+                                    </p:stCondLst>
+                                  </p:cTn>
+                                  <p:tgtEl>
+                                    <p:spTgt spid="8"/>
+                                  </p:tgtEl>
+                                  <p:attrNameLst>
+                                    <p:attrName>style.visibility</p:attrName>
+                                  </p:attrNameLst>
+                                </p:cBhvr>
+                                <p:to>
+                                  <p:strVal val="visible"/>
+                                </p:to>
+                              </p:set>
+                              <p:animEffect transition="in" filter="fade">
+                                <p:cBhvr>
+                                  <p:cTn id="9" dur="350">
+                                    <p:stCondLst>
+                                      <p:cond delay="0"/>
+                                    </p:stCondLst>
+                                  </p:cTn>
+                                  <p:tgtEl>
+                                    <p:spTgt spid="8"/>
+                                  </p:tgtEl>
+                                </p:cBhvr>
+                              </p:animEffect>
+                            </p:childTnLst>
+                          </p:cTn>
+                        </p:par>
+                        <p:par>
+                          <p:cTn id="10" fill="hold">
+                            <p:stCondLst>
+                              <p:cond delay="0"/>
+                            </p:stCondLst>
+                            <p:childTnLst>
+                              <p:set>
+                                <p:cBhvr>
+                                  <p:cTn id="11" dur="1" fill="hold">
+                                    <p:stCondLst>
+                                      <p:cond delay="0"/>
+                                    </p:stCondLst>
+                                  </p:cTn>
+                                  <p:tgtEl>
+                                    <p:spTgt spid="11"/>
+                                  </p:tgtEl>
+                                  <p:attrNameLst>
+                                    <p:attrName>style.visibility</p:attrName>
+                                  </p:attrNameLst>
+                                </p:cBhvr>
+                                <p:to>
+                                  <p:strVal val="visible"/>
+                                </p:to>
+                              </p:set>
+                              <p:animEffect transition="in" filter="fade">
+                                <p:cBhvr>
+                                  <p:cTn id="12" dur="350">
+                                    <p:stCondLst>
+                                      <p:cond delay="0"/>
+                                    </p:stCondLst>
+                                  </p:cTn>
+                                  <p:tgtEl>
+                                    <p:spTgt spid="11"/>
+                                  </p:tgtEl>
+                                </p:cBhvr>
+                              </p:animEffect>
+                            </p:childTnLst>
+                          </p:cTn>
+                        </p:par>
+                        <p:par>
+                          <p:cTn id="13" fill="hold">
+                            <p:stCondLst>
+                              <p:cond delay="0"/>
+                            </p:stCondLst>
+                            <p:childTnLst>
+                              <p:set>
+                                <p:cBhvr>
+                                  <p:cTn id="14" dur="1" fill="hold">
+                                    <p:stCondLst>
+                                      <p:cond delay="0"/>
+                                    </p:stCondLst>
+                                  </p:cTn>
+                                  <p:tgtEl>
+                                    <p:spTgt spid="14"/>
+                                  </p:tgtEl>
+                                  <p:attrNameLst>
+                                    <p:attrName>style.visibility</p:attrName>
+                                  </p:attrNameLst>
+                                </p:cBhvr>
+                                <p:to>
+                                  <p:strVal val="visible"/>
+                                </p:to>
+                              </p:set>
+                              <p:animEffect transition="in" filter="fade">
+                                <p:cBhvr>
+                                  <p:cTn id="15" dur="350">
+                                    <p:stCondLst>
+                                      <p:cond delay="0"/>
+                                    </p:stCondLst>
+                                  </p:cTn>
+                                  <p:tgtEl>
+                                    <p:spTgt spid="14"/>
+                                  </p:tgtEl>
+                                </p:cBhvr>
+                              </p:animEffect>
+                            </p:childTnLst>
+                          </p:cTn>
+                        </p:par>
+                        <p:par>
+                          <p:cTn id="16" fill="hold">
+                            <p:stCondLst>
+                              <p:cond delay="0"/>
+                            </p:stCondLst>
+                            <p:childTnLst>
+                              <p:set>
+                                <p:cBhvr>
+                                  <p:cTn id="17" dur="1" fill="hold">
+                                    <p:stCondLst>
+                                      <p:cond delay="0"/>
+                                    </p:stCondLst>
+                                  </p:cTn>
+                                  <p:tgtEl>
+                                    <p:spTgt spid="6"/>
+                                  </p:tgtEl>
+                                  <p:attrNameLst>
+                                    <p:attrName>style.visibility</p:attrName>
+                                  </p:attrNameLst>
+                                </p:cBhvr>
+                                <p:to>
+                                  <p:strVal val="visible"/>
+                                </p:to>
+                              </p:set>
+                              <p:animEffect transition="in" filter="fade">
+                                <p:cBhvr>
+                                  <p:cTn id="18" dur="350">
+                                    <p:stCondLst>
+                                      <p:cond delay="0"/>
+                                    </p:stCondLst>
+                                  </p:cTn>
+                                  <p:tgtEl>
+                                    <p:spTgt spid="6"/>
+                                  </p:tgtEl>
+                                </p:cBhvr>
+                              </p:animEffect>
+                            </p:childTnLst>
+                          </p:cTn>
+                        </p:par>
+                        <p:par>
+                          <p:cTn id="19" fill="hold">
+                            <p:stCondLst>
+                              <p:cond delay="0"/>
+                            </p:stCondLst>
+                            <p:childTnLst>
+                              <p:set>
+                                <p:cBhvr>
+                                  <p:cTn id="20" dur="1" fill="hold">
+                                    <p:stCondLst>
+                                      <p:cond delay="0"/>
+                                    </p:stCondLst>
+                                  </p:cTn>
+                                  <p:tgtEl>
+                                    <p:spTgt spid="9"/>
+                                  </p:tgtEl>
+                                  <p:attrNameLst>
+                                    <p:attrName>style.visibility</p:attrName>
+                                  </p:attrNameLst>
+                                </p:cBhvr>
+                                <p:to>
+                                  <p:strVal val="visible"/>
+                                </p:to>
+                              </p:set>
+                              <p:animEffect transition="in" filter="fade">
+                                <p:cBhvr>
+                                  <p:cTn id="21" dur="350">
+                                    <p:stCondLst>
+                                      <p:cond delay="0"/>
+                                    </p:stCondLst>
+                                  </p:cTn>
+                                  <p:tgtEl>
+                                    <p:spTgt spid="9"/>
+                                  </p:tgtEl>
+                                </p:cBhvr>
+                              </p:animEffect>
+                            </p:childTnLst>
+                          </p:cTn>
+                        </p:par>
+                        <p:par>
+                          <p:cTn id="22" fill="hold">
+                            <p:stCondLst>
+                              <p:cond delay="0"/>
+                            </p:stCondLst>
+                            <p:childTnLst>
+                              <p:set>
+                                <p:cBhvr>
+                                  <p:cTn id="23" dur="1" fill="hold">
+                                    <p:stCondLst>
+                                      <p:cond delay="0"/>
+                                    </p:stCondLst>
+                                  </p:cTn>
+                                  <p:tgtEl>
+                                    <p:spTgt spid="12"/>
+                                  </p:tgtEl>
+                                  <p:attrNameLst>
+                                    <p:attrName>style.visibility</p:attrName>
+                                  </p:attrNameLst>
+                                </p:cBhvr>
+                                <p:to>
+                                  <p:strVal val="visible"/>
+                                </p:to>
+                              </p:set>
+                              <p:animEffect transition="in" filter="fade">
+                                <p:cBhvr>
+                                  <p:cTn id="24" dur="350">
+                                    <p:stCondLst>
+                                      <p:cond delay="0"/>
+                                    </p:stCondLst>
+                                  </p:cTn>
+                                  <p:tgtEl>
+                                    <p:spTgt spid="12"/>
+                                  </p:tgtEl>
+                                </p:cBhvr>
+                              </p:animEffect>
+                            </p:childTnLst>
+                          </p:cTn>
+                        </p:par>
+                        <p:par>
+                          <p:cTn id="25" fill="hold">
+                            <p:stCondLst>
+                              <p:cond delay="0"/>
+                            </p:stCondLst>
+                            <p:childTnLst>
+                              <p:set>
+                                <p:cBhvr>
+                                  <p:cTn id="26" dur="1" fill="hold">
+                                    <p:stCondLst>
+                                      <p:cond delay="0"/>
+                                    </p:stCondLst>
+                                  </p:cTn>
+                                  <p:tgtEl>
+                                    <p:spTgt spid="15"/>
+                                  </p:tgtEl>
+                                  <p:attrNameLst>
+                                    <p:attrName>style.visibility</p:attrName>
+                                  </p:attrNameLst>
+                                </p:cBhvr>
+                                <p:to>
+                                  <p:strVal val="visible"/>
+                                </p:to>
+                              </p:set>
+                              <p:animEffect transition="in" filter="fade">
+                                <p:cBhvr>
+                                  <p:cTn id="27" dur="350">
+                                    <p:stCondLst>
+                                      <p:cond delay="0"/>
+                                    </p:stCondLst>
+                                  </p:cTn>
+                                  <p:tgtEl>
+                                    <p:spTgt spid="15"/>
+                                  </p:tgtEl>
+                                </p:cBhvr>
+                              </p:animEffect>
+                            </p:childTnLst>
+                          </p:cTn>
+                        </p:par>
+                      </p:childTnLst>
+                    </p:cTn>
+                  </p:par>
+                  <p:par>
+                    <p:cTn id="28" fill="hold">
+                      <p:stCondLst>
+                        <p:cond delay="0"/>
+                      </p:stCondLst>
+                      <p:childTnLst>
+                        <p:par>
+                          <p:cTn id="29" fill="hold">
+                            <p:stCondLst>
+                              <p:cond delay="0"/>
+                            </p:stCondLst>
+                            <p:childTnLst>
+                              <p:set>
+                                <p:cBhvr>
+                                  <p:cTn id="30" dur="1" fill="hold">
+                                    <p:stCondLst>
+                                      <p:cond delay="0"/>
+                                    </p:stCondLst>
+                                  </p:cTn>
+                                  <p:tgtEl>
+                                    <p:spTgt spid="7"/>
+                                  </p:tgtEl>
+                                  <p:attrNameLst>
+                                    <p:attrName>style.visibility</p:attrName>
+                                  </p:attrNameLst>
+                                </p:cBhvr>
+                                <p:to>
+                                  <p:strVal val="visible"/>
+                                </p:to>
+                              </p:set>
+                              <p:animEffect transition="in" filter="fade">
+                                <p:cBhvr>
+                                  <p:cTn id="31" dur="350">
+                                    <p:stCondLst>
+                                      <p:cond delay="0"/>
+                                    </p:stCondLst>
+                                  </p:cTn>
+                                  <p:tgtEl>
+                                    <p:spTgt spid="7"/>
+                                  </p:tgtEl>
+                                </p:cBhvr>
+                              </p:animEffect>
+                            </p:childTnLst>
+                          </p:cTn>
+                        </p:par>
+                        <p:par>
+                          <p:cTn id="32" fill="hold">
+                            <p:stCondLst>
+                              <p:cond delay="0"/>
+                            </p:stCondLst>
+                            <p:childTnLst>
+                              <p:set>
+                                <p:cBhvr>
+                                  <p:cTn id="33" dur="1" fill="hold">
+                                    <p:stCondLst>
+                                      <p:cond delay="0"/>
+                                    </p:stCondLst>
+                                  </p:cTn>
+                                  <p:tgtEl>
+                                    <p:spTgt spid="10"/>
+                                  </p:tgtEl>
+                                  <p:attrNameLst>
+                                    <p:attrName>style.visibility</p:attrName>
+                                  </p:attrNameLst>
+                                </p:cBhvr>
+                                <p:to>
+                                  <p:strVal val="visible"/>
+                                </p:to>
+                              </p:set>
+                              <p:animEffect transition="in" filter="fade">
+                                <p:cBhvr>
+                                  <p:cTn id="34" dur="350">
+                                    <p:stCondLst>
+                                      <p:cond delay="0"/>
+                                    </p:stCondLst>
+                                  </p:cTn>
+                                  <p:tgtEl>
+                                    <p:spTgt spid="10"/>
+                                  </p:tgtEl>
+                                </p:cBhvr>
+                              </p:animEffect>
+                            </p:childTnLst>
+                          </p:cTn>
+                        </p:par>
+                        <p:par>
+                          <p:cTn id="35" fill="hold">
+                            <p:stCondLst>
+                              <p:cond delay="0"/>
+                            </p:stCondLst>
+                            <p:childTnLst>
+                              <p:set>
+                                <p:cBhvr>
+                                  <p:cTn id="36" dur="1" fill="hold">
+                                    <p:stCondLst>
+                                      <p:cond delay="0"/>
+                                    </p:stCondLst>
+                                  </p:cTn>
+                                  <p:tgtEl>
+                                    <p:spTgt spid="13"/>
+                                  </p:tgtEl>
+                                  <p:attrNameLst>
+                                    <p:attrName>style.visibility</p:attrName>
+                                  </p:attrNameLst>
+                                </p:cBhvr>
+                                <p:to>
+                                  <p:strVal val="visible"/>
+                                </p:to>
+                              </p:set>
+                              <p:animEffect transition="in" filter="fade">
+                                <p:cBhvr>
+                                  <p:cTn id="37" dur="350">
+                                    <p:stCondLst>
+                                      <p:cond delay="0"/>
+                                    </p:stCondLst>
+                                  </p:cTn>
+                                  <p:tgtEl>
+                                    <p:spTgt spid="13"/>
+                                  </p:tgtEl>
+                                </p:cBhvr>
+                              </p:animEffect>
+                            </p:childTnLst>
+                          </p:cTn>
+                        </p:par>
+                        <p:par>
+                          <p:cTn id="38" fill="hold">
+                            <p:stCondLst>
+                              <p:cond delay="0"/>
+                            </p:stCondLst>
+                            <p:childTnLst>
+                              <p:set>
+                                <p:cBhvr>
+                                  <p:cTn id="39" dur="1" fill="hold">
+                                    <p:stCondLst>
+                                      <p:cond delay="0"/>
+                                    </p:stCondLst>
+                                  </p:cTn>
+                                  <p:tgtEl>
+                                    <p:spTgt spid="16"/>
+                                  </p:tgtEl>
+                                  <p:attrNameLst>
+                                    <p:attrName>style.visibility</p:attrName>
+                                  </p:attrNameLst>
+                                </p:cBhvr>
+                                <p:to>
+                                  <p:strVal val="visible"/>
+                                </p:to>
+                              </p:set>
+                              <p:animEffect transition="in" filter="fade">
+                                <p:cBhvr>
+                                  <p:cTn id="40" dur="350">
+                                    <p:stCondLst>
+                                      <p:cond delay="0"/>
+                                    </p:stCondLst>
+                                  </p:cTn>
+                                  <p:tgtEl>
+                                    <p:spTgt spid="16"/>
+                                  </p:tgtEl>
+                                </p:cBhvr>
+                              </p:animEffect>
+                            </p:childTnLst>
+                          </p:cTn>
+                        </p:par>
+                      </p:childTnLst>
+                    </p:cTn>
+                  </p:par>
+                </p:childTnLst>
+              </p:cTn>
+              <p:prevCondLst>
+                <p:cond evt="onPrev" delay="0"/>
+              </p:prevCondLst>
+              <p:nextCondLst>
+                <p:cond evt="onNext" delay="0"/>
+              </p:nextCondLst>
+            </p:seq>
+          </p:childTnLst>
+        </p:cTn>
+      </p:par>
+    </p:tnLst>
+  </p:timing>
 </p:sld>
 </file>
 

</xml_diff>